<commit_message>
Big change: you can now make the robot drive to a specific coordinate and can make the robot turn to a specific angle. You can also lightly communicate with the robot.
Also the firmware works yay it took me so long but now you can flash this on your robot to get 8kb storage
</commit_message>
<xml_diff>
--- a/pybricks-custom-firmware-src/micropython/lib/pico-sdk/lib/btstack/doc/manual/docs-template/picts/btstack-figs.pptx
+++ b/pybricks-custom-firmware-src/micropython/lib/pico-sdk/lib/btstack/doc/manual/docs-template/picts/btstack-figs.pptx
@@ -1,3 +1,118 @@
+
+<file path=ppt/presentation.xml><?xml version="1.0" encoding="utf-8"?>
+<p:presentation xmlns:a="http://schemas.openxmlformats.org/drawingml/2006/main" xmlns:r="http://schemas.openxmlformats.org/officeDocument/2006/relationships" xmlns:mc="http://schemas.openxmlformats.org/markup-compatibility/2006" xmlns:mv="urn:schemas-microsoft-com:mac:vml" xmlns:p="http://schemas.openxmlformats.org/presentationml/2006/main" mc:Ignorable="mv" mc:PreserveAttributes="mv:*" saveSubsetFonts="1" autoCompressPictures="0">
+  <p:sldMasterIdLst>
+    <p:sldMasterId r:id="rId1"/>
+  </p:sldMasterIdLst>
+  <p:notesMasterIdLst>
+    <p:notesMasterId r:id="rId4"/>
+  </p:notesMasterIdLst>
+  <p:handoutMasterIdLst>
+    <p:handoutMasterId r:id="rId5"/>
+  </p:handoutMasterIdLst>
+  <p:sldIdLst>
+    <p:sldId id="269" r:id="rId2"/>
+    <p:sldId id="270" r:id="rId3"/>
+  </p:sldIdLst>
+  <p:sldSz cx="9144000" cy="6858000" type="screen4x3"/>
+  <p:notesSz cx="9144000" cy="6858000"/>
+  <p:defaultTextStyle>
+    <a:defPPr>
+      <a:defRPr lang="en-US"/>
+    </a:defPPr>
+    <a:lvl1pPr marL="0" algn="l" defTabSz="457200" rtl="0" eaLnBrk="1" latinLnBrk="0" hangingPunct="1">
+      <a:defRPr sz="1800" kern="1200">
+        <a:solidFill>
+          <a:schemeClr val="tx1"/>
+        </a:solidFill>
+        <a:latin typeface="+mn-lt"/>
+        <a:ea typeface="+mn-ea"/>
+        <a:cs typeface="+mn-cs"/>
+      </a:defRPr>
+    </a:lvl1pPr>
+    <a:lvl2pPr marL="457200" algn="l" defTabSz="457200" rtl="0" eaLnBrk="1" latinLnBrk="0" hangingPunct="1">
+      <a:defRPr sz="1800" kern="1200">
+        <a:solidFill>
+          <a:schemeClr val="tx1"/>
+        </a:solidFill>
+        <a:latin typeface="+mn-lt"/>
+        <a:ea typeface="+mn-ea"/>
+        <a:cs typeface="+mn-cs"/>
+      </a:defRPr>
+    </a:lvl2pPr>
+    <a:lvl3pPr marL="914400" algn="l" defTabSz="457200" rtl="0" eaLnBrk="1" latinLnBrk="0" hangingPunct="1">
+      <a:defRPr sz="1800" kern="1200">
+        <a:solidFill>
+          <a:schemeClr val="tx1"/>
+        </a:solidFill>
+        <a:latin typeface="+mn-lt"/>
+        <a:ea typeface="+mn-ea"/>
+        <a:cs typeface="+mn-cs"/>
+      </a:defRPr>
+    </a:lvl3pPr>
+    <a:lvl4pPr marL="1371600" algn="l" defTabSz="457200" rtl="0" eaLnBrk="1" latinLnBrk="0" hangingPunct="1">
+      <a:defRPr sz="1800" kern="1200">
+        <a:solidFill>
+          <a:schemeClr val="tx1"/>
+        </a:solidFill>
+        <a:latin typeface="+mn-lt"/>
+        <a:ea typeface="+mn-ea"/>
+        <a:cs typeface="+mn-cs"/>
+      </a:defRPr>
+    </a:lvl4pPr>
+    <a:lvl5pPr marL="1828800" algn="l" defTabSz="457200" rtl="0" eaLnBrk="1" latinLnBrk="0" hangingPunct="1">
+      <a:defRPr sz="1800" kern="1200">
+        <a:solidFill>
+          <a:schemeClr val="tx1"/>
+        </a:solidFill>
+        <a:latin typeface="+mn-lt"/>
+        <a:ea typeface="+mn-ea"/>
+        <a:cs typeface="+mn-cs"/>
+      </a:defRPr>
+    </a:lvl5pPr>
+    <a:lvl6pPr marL="2286000" algn="l" defTabSz="457200" rtl="0" eaLnBrk="1" latinLnBrk="0" hangingPunct="1">
+      <a:defRPr sz="1800" kern="1200">
+        <a:solidFill>
+          <a:schemeClr val="tx1"/>
+        </a:solidFill>
+        <a:latin typeface="+mn-lt"/>
+        <a:ea typeface="+mn-ea"/>
+        <a:cs typeface="+mn-cs"/>
+      </a:defRPr>
+    </a:lvl6pPr>
+    <a:lvl7pPr marL="2743200" algn="l" defTabSz="457200" rtl="0" eaLnBrk="1" latinLnBrk="0" hangingPunct="1">
+      <a:defRPr sz="1800" kern="1200">
+        <a:solidFill>
+          <a:schemeClr val="tx1"/>
+        </a:solidFill>
+        <a:latin typeface="+mn-lt"/>
+        <a:ea typeface="+mn-ea"/>
+        <a:cs typeface="+mn-cs"/>
+      </a:defRPr>
+    </a:lvl7pPr>
+    <a:lvl8pPr marL="3200400" algn="l" defTabSz="457200" rtl="0" eaLnBrk="1" latinLnBrk="0" hangingPunct="1">
+      <a:defRPr sz="1800" kern="1200">
+        <a:solidFill>
+          <a:schemeClr val="tx1"/>
+        </a:solidFill>
+        <a:latin typeface="+mn-lt"/>
+        <a:ea typeface="+mn-ea"/>
+        <a:cs typeface="+mn-cs"/>
+      </a:defRPr>
+    </a:lvl8pPr>
+    <a:lvl9pPr marL="3657600" algn="l" defTabSz="457200" rtl="0" eaLnBrk="1" latinLnBrk="0" hangingPunct="1">
+      <a:defRPr sz="1800" kern="1200">
+        <a:solidFill>
+          <a:schemeClr val="tx1"/>
+        </a:solidFill>
+        <a:latin typeface="+mn-lt"/>
+        <a:ea typeface="+mn-ea"/>
+        <a:cs typeface="+mn-cs"/>
+      </a:defRPr>
+    </a:lvl9pPr>
+  </p:defaultTextStyle>
+</p:presentation>
+</file>
 
 <file path=ppt/handoutMasters/handoutMaster1.xml><?xml version="1.0" encoding="utf-8"?>
 <p:handoutMaster xmlns:a="http://schemas.openxmlformats.org/drawingml/2006/main" xmlns:r="http://schemas.openxmlformats.org/officeDocument/2006/relationships" xmlns:mc="http://schemas.openxmlformats.org/markup-compatibility/2006" xmlns:mv="urn:schemas-microsoft-com:mac:vml" xmlns:p="http://schemas.openxmlformats.org/presentationml/2006/main" mc:Ignorable="mv" mc:PreserveAttributes="mv:*">
@@ -510,6 +625,1120 @@
 </p:notesMaster>
 </file>
 
+<file path=ppt/notesSlides/notesSlide1.xml><?xml version="1.0" encoding="utf-8"?>
+<p:notes xmlns:a="http://schemas.openxmlformats.org/drawingml/2006/main" xmlns:r="http://schemas.openxmlformats.org/officeDocument/2006/relationships" xmlns:mc="http://schemas.openxmlformats.org/markup-compatibility/2006" xmlns:mv="urn:schemas-microsoft-com:mac:vml" xmlns:p="http://schemas.openxmlformats.org/presentationml/2006/main" mc:Ignorable="mv" mc:PreserveAttributes="mv:*">
+  <p:cSld>
+    <p:spTree>
+      <p:nvGrpSpPr>
+        <p:cNvPr id="1" name=""/>
+        <p:cNvGrpSpPr/>
+        <p:nvPr/>
+      </p:nvGrpSpPr>
+      <p:grpSpPr>
+        <a:xfrm>
+          <a:off x="0" y="0"/>
+          <a:ext cx="0" cy="0"/>
+          <a:chOff x="0" y="0"/>
+          <a:chExt cx="0" cy="0"/>
+        </a:xfrm>
+      </p:grpSpPr>
+      <p:sp>
+        <p:nvSpPr>
+          <p:cNvPr id="2" name="Slide Image Placeholder 1"/>
+          <p:cNvSpPr>
+            <a:spLocks noGrp="1" noRot="1" noChangeAspect="1"/>
+          </p:cNvSpPr>
+          <p:nvPr>
+            <p:ph type="sldImg"/>
+          </p:nvPr>
+        </p:nvSpPr>
+        <p:spPr/>
+      </p:sp>
+      <p:sp>
+        <p:nvSpPr>
+          <p:cNvPr id="3" name="Notes Placeholder 2"/>
+          <p:cNvSpPr>
+            <a:spLocks noGrp="1"/>
+          </p:cNvSpPr>
+          <p:nvPr>
+            <p:ph type="body" idx="1"/>
+          </p:nvPr>
+        </p:nvSpPr>
+        <p:spPr/>
+        <p:txBody>
+          <a:bodyPr>
+            <a:normAutofit/>
+          </a:bodyPr>
+          <a:lstStyle/>
+          <a:p>
+            <a:pPr>
+              <a:buFontTx/>
+              <a:buChar char="-"/>
+            </a:pPr>
+            <a:r>
+              <a:rPr lang="en-US" dirty="0" smtClean="0"/>
+              <a:t>Do not have: SCO manager, OBEX</a:t>
+            </a:r>
+          </a:p>
+          <a:p>
+            <a:pPr>
+              <a:buFontTx/>
+              <a:buChar char="-"/>
+            </a:pPr>
+            <a:r>
+              <a:rPr lang="en-US" dirty="0" smtClean="0"/>
+              <a:t>Extra have: </a:t>
+            </a:r>
+          </a:p>
+          <a:p>
+            <a:pPr>
+              <a:buFontTx/>
+              <a:buChar char="-"/>
+            </a:pPr>
+            <a:endParaRPr lang="en-US" dirty="0" smtClean="0"/>
+          </a:p>
+          <a:p>
+            <a:pPr>
+              <a:buFontTx/>
+              <a:buChar char="-"/>
+            </a:pPr>
+            <a:r>
+              <a:rPr lang="en-US" dirty="0" smtClean="0"/>
+              <a:t>Dual/single</a:t>
+            </a:r>
+            <a:r>
+              <a:rPr lang="en-US" baseline="0" dirty="0" smtClean="0"/>
+              <a:t> mode arch </a:t>
+            </a:r>
+            <a:endParaRPr lang="en-US" dirty="0"/>
+          </a:p>
+        </p:txBody>
+      </p:sp>
+      <p:sp>
+        <p:nvSpPr>
+          <p:cNvPr id="4" name="Slide Number Placeholder 3"/>
+          <p:cNvSpPr>
+            <a:spLocks noGrp="1"/>
+          </p:cNvSpPr>
+          <p:nvPr>
+            <p:ph type="sldNum" sz="quarter" idx="10"/>
+          </p:nvPr>
+        </p:nvSpPr>
+        <p:spPr/>
+        <p:txBody>
+          <a:bodyPr/>
+          <a:lstStyle/>
+          <a:p>
+            <a:fld id="{E733BD58-334B-7C4E-9819-371AF0C02F66}" type="slidenum">
+              <a:rPr lang="en-US" smtClean="0"/>
+              <a:pPr/>
+              <a:t>1</a:t>
+            </a:fld>
+            <a:endParaRPr lang="en-US"/>
+          </a:p>
+        </p:txBody>
+      </p:sp>
+    </p:spTree>
+  </p:cSld>
+  <p:clrMapOvr>
+    <a:masterClrMapping/>
+  </p:clrMapOvr>
+</p:notes>
+</file>
+
+<file path=ppt/slideLayouts/slideLayout1.xml><?xml version="1.0" encoding="utf-8"?>
+<p:sldLayout xmlns:a="http://schemas.openxmlformats.org/drawingml/2006/main" xmlns:r="http://schemas.openxmlformats.org/officeDocument/2006/relationships" xmlns:mc="http://schemas.openxmlformats.org/markup-compatibility/2006" xmlns:mv="urn:schemas-microsoft-com:mac:vml" xmlns:p="http://schemas.openxmlformats.org/presentationml/2006/main" mc:Ignorable="mv" mc:PreserveAttributes="mv:*" type="title" preserve="1">
+  <p:cSld name="Title Slide">
+    <p:spTree>
+      <p:nvGrpSpPr>
+        <p:cNvPr id="1" name=""/>
+        <p:cNvGrpSpPr/>
+        <p:nvPr/>
+      </p:nvGrpSpPr>
+      <p:grpSpPr>
+        <a:xfrm>
+          <a:off x="0" y="0"/>
+          <a:ext cx="0" cy="0"/>
+          <a:chOff x="0" y="0"/>
+          <a:chExt cx="0" cy="0"/>
+        </a:xfrm>
+      </p:grpSpPr>
+      <p:sp>
+        <p:nvSpPr>
+          <p:cNvPr id="2" name="Title 1"/>
+          <p:cNvSpPr>
+            <a:spLocks noGrp="1"/>
+          </p:cNvSpPr>
+          <p:nvPr>
+            <p:ph type="ctrTitle"/>
+          </p:nvPr>
+        </p:nvSpPr>
+        <p:spPr>
+          <a:xfrm>
+            <a:off x="685800" y="2130427"/>
+            <a:ext cx="7772400" cy="1470025"/>
+          </a:xfrm>
+        </p:spPr>
+        <p:txBody>
+          <a:bodyPr/>
+          <a:lstStyle/>
+          <a:p>
+            <a:r>
+              <a:rPr lang="en-US" smtClean="0"/>
+              <a:t>Click to edit Master title style</a:t>
+            </a:r>
+            <a:endParaRPr lang="en-US"/>
+          </a:p>
+        </p:txBody>
+      </p:sp>
+      <p:sp>
+        <p:nvSpPr>
+          <p:cNvPr id="3" name="Subtitle 2"/>
+          <p:cNvSpPr>
+            <a:spLocks noGrp="1"/>
+          </p:cNvSpPr>
+          <p:nvPr>
+            <p:ph type="subTitle" idx="1"/>
+          </p:nvPr>
+        </p:nvSpPr>
+        <p:spPr>
+          <a:xfrm>
+            <a:off x="1371600" y="3886200"/>
+            <a:ext cx="6400800" cy="1752600"/>
+          </a:xfrm>
+        </p:spPr>
+        <p:txBody>
+          <a:bodyPr/>
+          <a:lstStyle>
+            <a:lvl1pPr marL="0" indent="0" algn="ctr">
+              <a:buNone/>
+              <a:defRPr>
+                <a:solidFill>
+                  <a:schemeClr val="tx1">
+                    <a:tint val="75000"/>
+                  </a:schemeClr>
+                </a:solidFill>
+              </a:defRPr>
+            </a:lvl1pPr>
+            <a:lvl2pPr marL="457200" indent="0" algn="ctr">
+              <a:buNone/>
+              <a:defRPr>
+                <a:solidFill>
+                  <a:schemeClr val="tx1">
+                    <a:tint val="75000"/>
+                  </a:schemeClr>
+                </a:solidFill>
+              </a:defRPr>
+            </a:lvl2pPr>
+            <a:lvl3pPr marL="914400" indent="0" algn="ctr">
+              <a:buNone/>
+              <a:defRPr>
+                <a:solidFill>
+                  <a:schemeClr val="tx1">
+                    <a:tint val="75000"/>
+                  </a:schemeClr>
+                </a:solidFill>
+              </a:defRPr>
+            </a:lvl3pPr>
+            <a:lvl4pPr marL="1371600" indent="0" algn="ctr">
+              <a:buNone/>
+              <a:defRPr>
+                <a:solidFill>
+                  <a:schemeClr val="tx1">
+                    <a:tint val="75000"/>
+                  </a:schemeClr>
+                </a:solidFill>
+              </a:defRPr>
+            </a:lvl4pPr>
+            <a:lvl5pPr marL="1828800" indent="0" algn="ctr">
+              <a:buNone/>
+              <a:defRPr>
+                <a:solidFill>
+                  <a:schemeClr val="tx1">
+                    <a:tint val="75000"/>
+                  </a:schemeClr>
+                </a:solidFill>
+              </a:defRPr>
+            </a:lvl5pPr>
+            <a:lvl6pPr marL="2286000" indent="0" algn="ctr">
+              <a:buNone/>
+              <a:defRPr>
+                <a:solidFill>
+                  <a:schemeClr val="tx1">
+                    <a:tint val="75000"/>
+                  </a:schemeClr>
+                </a:solidFill>
+              </a:defRPr>
+            </a:lvl6pPr>
+            <a:lvl7pPr marL="2743200" indent="0" algn="ctr">
+              <a:buNone/>
+              <a:defRPr>
+                <a:solidFill>
+                  <a:schemeClr val="tx1">
+                    <a:tint val="75000"/>
+                  </a:schemeClr>
+                </a:solidFill>
+              </a:defRPr>
+            </a:lvl7pPr>
+            <a:lvl8pPr marL="3200400" indent="0" algn="ctr">
+              <a:buNone/>
+              <a:defRPr>
+                <a:solidFill>
+                  <a:schemeClr val="tx1">
+                    <a:tint val="75000"/>
+                  </a:schemeClr>
+                </a:solidFill>
+              </a:defRPr>
+            </a:lvl8pPr>
+            <a:lvl9pPr marL="3657600" indent="0" algn="ctr">
+              <a:buNone/>
+              <a:defRPr>
+                <a:solidFill>
+                  <a:schemeClr val="tx1">
+                    <a:tint val="75000"/>
+                  </a:schemeClr>
+                </a:solidFill>
+              </a:defRPr>
+            </a:lvl9pPr>
+          </a:lstStyle>
+          <a:p>
+            <a:r>
+              <a:rPr lang="en-US" smtClean="0"/>
+              <a:t>Click to edit Master subtitle style</a:t>
+            </a:r>
+            <a:endParaRPr lang="en-US"/>
+          </a:p>
+        </p:txBody>
+      </p:sp>
+      <p:sp>
+        <p:nvSpPr>
+          <p:cNvPr id="4" name="Date Placeholder 3"/>
+          <p:cNvSpPr>
+            <a:spLocks noGrp="1"/>
+          </p:cNvSpPr>
+          <p:nvPr>
+            <p:ph type="dt" sz="half" idx="10"/>
+          </p:nvPr>
+        </p:nvSpPr>
+        <p:spPr/>
+        <p:txBody>
+          <a:bodyPr/>
+          <a:lstStyle/>
+          <a:p>
+            <a:fld id="{45253105-6222-E44C-A3C9-B345BB2DB333}" type="datetimeFigureOut">
+              <a:rPr lang="en-US" smtClean="0"/>
+              <a:pPr/>
+              <a:t>6/20/14</a:t>
+            </a:fld>
+            <a:endParaRPr lang="en-US"/>
+          </a:p>
+        </p:txBody>
+      </p:sp>
+      <p:sp>
+        <p:nvSpPr>
+          <p:cNvPr id="5" name="Footer Placeholder 4"/>
+          <p:cNvSpPr>
+            <a:spLocks noGrp="1"/>
+          </p:cNvSpPr>
+          <p:nvPr>
+            <p:ph type="ftr" sz="quarter" idx="11"/>
+          </p:nvPr>
+        </p:nvSpPr>
+        <p:spPr/>
+        <p:txBody>
+          <a:bodyPr/>
+          <a:lstStyle/>
+          <a:p>
+            <a:endParaRPr lang="en-US"/>
+          </a:p>
+        </p:txBody>
+      </p:sp>
+      <p:sp>
+        <p:nvSpPr>
+          <p:cNvPr id="6" name="Slide Number Placeholder 5"/>
+          <p:cNvSpPr>
+            <a:spLocks noGrp="1"/>
+          </p:cNvSpPr>
+          <p:nvPr>
+            <p:ph type="sldNum" sz="quarter" idx="12"/>
+          </p:nvPr>
+        </p:nvSpPr>
+        <p:spPr/>
+        <p:txBody>
+          <a:bodyPr/>
+          <a:lstStyle/>
+          <a:p>
+            <a:fld id="{A399DE09-9C7D-4B4C-A05E-F50BAD98C8AA}" type="slidenum">
+              <a:rPr lang="en-US" smtClean="0"/>
+              <a:pPr/>
+              <a:t>‹#›</a:t>
+            </a:fld>
+            <a:endParaRPr lang="en-US"/>
+          </a:p>
+        </p:txBody>
+      </p:sp>
+    </p:spTree>
+  </p:cSld>
+  <p:clrMapOvr>
+    <a:masterClrMapping/>
+  </p:clrMapOvr>
+</p:sldLayout>
+</file>
+
+<file path=ppt/slideLayouts/slideLayout10.xml><?xml version="1.0" encoding="utf-8"?>
+<p:sldLayout xmlns:a="http://schemas.openxmlformats.org/drawingml/2006/main" xmlns:r="http://schemas.openxmlformats.org/officeDocument/2006/relationships" xmlns:mc="http://schemas.openxmlformats.org/markup-compatibility/2006" xmlns:mv="urn:schemas-microsoft-com:mac:vml" xmlns:p="http://schemas.openxmlformats.org/presentationml/2006/main" mc:Ignorable="mv" mc:PreserveAttributes="mv:*" type="vertTx" preserve="1">
+  <p:cSld name="Title and Vertical Text">
+    <p:spTree>
+      <p:nvGrpSpPr>
+        <p:cNvPr id="1" name=""/>
+        <p:cNvGrpSpPr/>
+        <p:nvPr/>
+      </p:nvGrpSpPr>
+      <p:grpSpPr>
+        <a:xfrm>
+          <a:off x="0" y="0"/>
+          <a:ext cx="0" cy="0"/>
+          <a:chOff x="0" y="0"/>
+          <a:chExt cx="0" cy="0"/>
+        </a:xfrm>
+      </p:grpSpPr>
+      <p:sp>
+        <p:nvSpPr>
+          <p:cNvPr id="2" name="Title 1"/>
+          <p:cNvSpPr>
+            <a:spLocks noGrp="1"/>
+          </p:cNvSpPr>
+          <p:nvPr>
+            <p:ph type="title"/>
+          </p:nvPr>
+        </p:nvSpPr>
+        <p:spPr/>
+        <p:txBody>
+          <a:bodyPr/>
+          <a:lstStyle/>
+          <a:p>
+            <a:r>
+              <a:rPr lang="en-US" smtClean="0"/>
+              <a:t>Click to edit Master title style</a:t>
+            </a:r>
+            <a:endParaRPr lang="en-US"/>
+          </a:p>
+        </p:txBody>
+      </p:sp>
+      <p:sp>
+        <p:nvSpPr>
+          <p:cNvPr id="3" name="Vertical Text Placeholder 2"/>
+          <p:cNvSpPr>
+            <a:spLocks noGrp="1"/>
+          </p:cNvSpPr>
+          <p:nvPr>
+            <p:ph type="body" orient="vert" idx="1"/>
+          </p:nvPr>
+        </p:nvSpPr>
+        <p:spPr/>
+        <p:txBody>
+          <a:bodyPr vert="eaVert"/>
+          <a:lstStyle/>
+          <a:p>
+            <a:pPr lvl="0"/>
+            <a:r>
+              <a:rPr lang="en-US" smtClean="0"/>
+              <a:t>Click to edit Master text styles</a:t>
+            </a:r>
+          </a:p>
+          <a:p>
+            <a:pPr lvl="1"/>
+            <a:r>
+              <a:rPr lang="en-US" smtClean="0"/>
+              <a:t>Second level</a:t>
+            </a:r>
+          </a:p>
+          <a:p>
+            <a:pPr lvl="2"/>
+            <a:r>
+              <a:rPr lang="en-US" smtClean="0"/>
+              <a:t>Third level</a:t>
+            </a:r>
+          </a:p>
+          <a:p>
+            <a:pPr lvl="3"/>
+            <a:r>
+              <a:rPr lang="en-US" smtClean="0"/>
+              <a:t>Fourth level</a:t>
+            </a:r>
+          </a:p>
+          <a:p>
+            <a:pPr lvl="4"/>
+            <a:r>
+              <a:rPr lang="en-US" smtClean="0"/>
+              <a:t>Fifth level</a:t>
+            </a:r>
+            <a:endParaRPr lang="en-US"/>
+          </a:p>
+        </p:txBody>
+      </p:sp>
+      <p:sp>
+        <p:nvSpPr>
+          <p:cNvPr id="4" name="Date Placeholder 3"/>
+          <p:cNvSpPr>
+            <a:spLocks noGrp="1"/>
+          </p:cNvSpPr>
+          <p:nvPr>
+            <p:ph type="dt" sz="half" idx="10"/>
+          </p:nvPr>
+        </p:nvSpPr>
+        <p:spPr/>
+        <p:txBody>
+          <a:bodyPr/>
+          <a:lstStyle/>
+          <a:p>
+            <a:fld id="{45253105-6222-E44C-A3C9-B345BB2DB333}" type="datetimeFigureOut">
+              <a:rPr lang="en-US" smtClean="0"/>
+              <a:pPr/>
+              <a:t>6/20/14</a:t>
+            </a:fld>
+            <a:endParaRPr lang="en-US"/>
+          </a:p>
+        </p:txBody>
+      </p:sp>
+      <p:sp>
+        <p:nvSpPr>
+          <p:cNvPr id="5" name="Footer Placeholder 4"/>
+          <p:cNvSpPr>
+            <a:spLocks noGrp="1"/>
+          </p:cNvSpPr>
+          <p:nvPr>
+            <p:ph type="ftr" sz="quarter" idx="11"/>
+          </p:nvPr>
+        </p:nvSpPr>
+        <p:spPr/>
+        <p:txBody>
+          <a:bodyPr/>
+          <a:lstStyle/>
+          <a:p>
+            <a:endParaRPr lang="en-US"/>
+          </a:p>
+        </p:txBody>
+      </p:sp>
+      <p:sp>
+        <p:nvSpPr>
+          <p:cNvPr id="6" name="Slide Number Placeholder 5"/>
+          <p:cNvSpPr>
+            <a:spLocks noGrp="1"/>
+          </p:cNvSpPr>
+          <p:nvPr>
+            <p:ph type="sldNum" sz="quarter" idx="12"/>
+          </p:nvPr>
+        </p:nvSpPr>
+        <p:spPr/>
+        <p:txBody>
+          <a:bodyPr/>
+          <a:lstStyle/>
+          <a:p>
+            <a:fld id="{A399DE09-9C7D-4B4C-A05E-F50BAD98C8AA}" type="slidenum">
+              <a:rPr lang="en-US" smtClean="0"/>
+              <a:pPr/>
+              <a:t>‹#›</a:t>
+            </a:fld>
+            <a:endParaRPr lang="en-US"/>
+          </a:p>
+        </p:txBody>
+      </p:sp>
+    </p:spTree>
+  </p:cSld>
+  <p:clrMapOvr>
+    <a:masterClrMapping/>
+  </p:clrMapOvr>
+</p:sldLayout>
+</file>
+
+<file path=ppt/slideLayouts/slideLayout11.xml><?xml version="1.0" encoding="utf-8"?>
+<p:sldLayout xmlns:a="http://schemas.openxmlformats.org/drawingml/2006/main" xmlns:r="http://schemas.openxmlformats.org/officeDocument/2006/relationships" xmlns:mc="http://schemas.openxmlformats.org/markup-compatibility/2006" xmlns:mv="urn:schemas-microsoft-com:mac:vml" xmlns:p="http://schemas.openxmlformats.org/presentationml/2006/main" mc:Ignorable="mv" mc:PreserveAttributes="mv:*" type="vertTitleAndTx" preserve="1">
+  <p:cSld name="Vertical Title and Text">
+    <p:spTree>
+      <p:nvGrpSpPr>
+        <p:cNvPr id="1" name=""/>
+        <p:cNvGrpSpPr/>
+        <p:nvPr/>
+      </p:nvGrpSpPr>
+      <p:grpSpPr>
+        <a:xfrm>
+          <a:off x="0" y="0"/>
+          <a:ext cx="0" cy="0"/>
+          <a:chOff x="0" y="0"/>
+          <a:chExt cx="0" cy="0"/>
+        </a:xfrm>
+      </p:grpSpPr>
+      <p:sp>
+        <p:nvSpPr>
+          <p:cNvPr id="2" name="Vertical Title 1"/>
+          <p:cNvSpPr>
+            <a:spLocks noGrp="1"/>
+          </p:cNvSpPr>
+          <p:nvPr>
+            <p:ph type="title" orient="vert"/>
+          </p:nvPr>
+        </p:nvSpPr>
+        <p:spPr>
+          <a:xfrm>
+            <a:off x="6629400" y="274640"/>
+            <a:ext cx="2057400" cy="5851525"/>
+          </a:xfrm>
+        </p:spPr>
+        <p:txBody>
+          <a:bodyPr vert="eaVert"/>
+          <a:lstStyle/>
+          <a:p>
+            <a:r>
+              <a:rPr lang="en-US" smtClean="0"/>
+              <a:t>Click to edit Master title style</a:t>
+            </a:r>
+            <a:endParaRPr lang="en-US"/>
+          </a:p>
+        </p:txBody>
+      </p:sp>
+      <p:sp>
+        <p:nvSpPr>
+          <p:cNvPr id="3" name="Vertical Text Placeholder 2"/>
+          <p:cNvSpPr>
+            <a:spLocks noGrp="1"/>
+          </p:cNvSpPr>
+          <p:nvPr>
+            <p:ph type="body" orient="vert" idx="1"/>
+          </p:nvPr>
+        </p:nvSpPr>
+        <p:spPr>
+          <a:xfrm>
+            <a:off x="457200" y="274640"/>
+            <a:ext cx="6019800" cy="5851525"/>
+          </a:xfrm>
+        </p:spPr>
+        <p:txBody>
+          <a:bodyPr vert="eaVert"/>
+          <a:lstStyle/>
+          <a:p>
+            <a:pPr lvl="0"/>
+            <a:r>
+              <a:rPr lang="en-US" smtClean="0"/>
+              <a:t>Click to edit Master text styles</a:t>
+            </a:r>
+          </a:p>
+          <a:p>
+            <a:pPr lvl="1"/>
+            <a:r>
+              <a:rPr lang="en-US" smtClean="0"/>
+              <a:t>Second level</a:t>
+            </a:r>
+          </a:p>
+          <a:p>
+            <a:pPr lvl="2"/>
+            <a:r>
+              <a:rPr lang="en-US" smtClean="0"/>
+              <a:t>Third level</a:t>
+            </a:r>
+          </a:p>
+          <a:p>
+            <a:pPr lvl="3"/>
+            <a:r>
+              <a:rPr lang="en-US" smtClean="0"/>
+              <a:t>Fourth level</a:t>
+            </a:r>
+          </a:p>
+          <a:p>
+            <a:pPr lvl="4"/>
+            <a:r>
+              <a:rPr lang="en-US" smtClean="0"/>
+              <a:t>Fifth level</a:t>
+            </a:r>
+            <a:endParaRPr lang="en-US"/>
+          </a:p>
+        </p:txBody>
+      </p:sp>
+      <p:sp>
+        <p:nvSpPr>
+          <p:cNvPr id="4" name="Date Placeholder 3"/>
+          <p:cNvSpPr>
+            <a:spLocks noGrp="1"/>
+          </p:cNvSpPr>
+          <p:nvPr>
+            <p:ph type="dt" sz="half" idx="10"/>
+          </p:nvPr>
+        </p:nvSpPr>
+        <p:spPr/>
+        <p:txBody>
+          <a:bodyPr/>
+          <a:lstStyle/>
+          <a:p>
+            <a:fld id="{45253105-6222-E44C-A3C9-B345BB2DB333}" type="datetimeFigureOut">
+              <a:rPr lang="en-US" smtClean="0"/>
+              <a:pPr/>
+              <a:t>6/20/14</a:t>
+            </a:fld>
+            <a:endParaRPr lang="en-US"/>
+          </a:p>
+        </p:txBody>
+      </p:sp>
+      <p:sp>
+        <p:nvSpPr>
+          <p:cNvPr id="5" name="Footer Placeholder 4"/>
+          <p:cNvSpPr>
+            <a:spLocks noGrp="1"/>
+          </p:cNvSpPr>
+          <p:nvPr>
+            <p:ph type="ftr" sz="quarter" idx="11"/>
+          </p:nvPr>
+        </p:nvSpPr>
+        <p:spPr/>
+        <p:txBody>
+          <a:bodyPr/>
+          <a:lstStyle/>
+          <a:p>
+            <a:endParaRPr lang="en-US"/>
+          </a:p>
+        </p:txBody>
+      </p:sp>
+      <p:sp>
+        <p:nvSpPr>
+          <p:cNvPr id="6" name="Slide Number Placeholder 5"/>
+          <p:cNvSpPr>
+            <a:spLocks noGrp="1"/>
+          </p:cNvSpPr>
+          <p:nvPr>
+            <p:ph type="sldNum" sz="quarter" idx="12"/>
+          </p:nvPr>
+        </p:nvSpPr>
+        <p:spPr/>
+        <p:txBody>
+          <a:bodyPr/>
+          <a:lstStyle/>
+          <a:p>
+            <a:fld id="{A399DE09-9C7D-4B4C-A05E-F50BAD98C8AA}" type="slidenum">
+              <a:rPr lang="en-US" smtClean="0"/>
+              <a:pPr/>
+              <a:t>‹#›</a:t>
+            </a:fld>
+            <a:endParaRPr lang="en-US"/>
+          </a:p>
+        </p:txBody>
+      </p:sp>
+    </p:spTree>
+  </p:cSld>
+  <p:clrMapOvr>
+    <a:masterClrMapping/>
+  </p:clrMapOvr>
+</p:sldLayout>
+</file>
+
+<file path=ppt/slideLayouts/slideLayout2.xml><?xml version="1.0" encoding="utf-8"?>
+<p:sldLayout xmlns:a="http://schemas.openxmlformats.org/drawingml/2006/main" xmlns:r="http://schemas.openxmlformats.org/officeDocument/2006/relationships" xmlns:mc="http://schemas.openxmlformats.org/markup-compatibility/2006" xmlns:mv="urn:schemas-microsoft-com:mac:vml" xmlns:p="http://schemas.openxmlformats.org/presentationml/2006/main" mc:Ignorable="mv" mc:PreserveAttributes="mv:*" type="obj" preserve="1">
+  <p:cSld name="Title and Content">
+    <p:spTree>
+      <p:nvGrpSpPr>
+        <p:cNvPr id="1" name=""/>
+        <p:cNvGrpSpPr/>
+        <p:nvPr/>
+      </p:nvGrpSpPr>
+      <p:grpSpPr>
+        <a:xfrm>
+          <a:off x="0" y="0"/>
+          <a:ext cx="0" cy="0"/>
+          <a:chOff x="0" y="0"/>
+          <a:chExt cx="0" cy="0"/>
+        </a:xfrm>
+      </p:grpSpPr>
+      <p:sp>
+        <p:nvSpPr>
+          <p:cNvPr id="2" name="Title 1"/>
+          <p:cNvSpPr>
+            <a:spLocks noGrp="1"/>
+          </p:cNvSpPr>
+          <p:nvPr>
+            <p:ph type="title"/>
+          </p:nvPr>
+        </p:nvSpPr>
+        <p:spPr/>
+        <p:txBody>
+          <a:bodyPr/>
+          <a:lstStyle/>
+          <a:p>
+            <a:r>
+              <a:rPr lang="en-US" smtClean="0"/>
+              <a:t>Click to edit Master title style</a:t>
+            </a:r>
+            <a:endParaRPr lang="en-US"/>
+          </a:p>
+        </p:txBody>
+      </p:sp>
+      <p:sp>
+        <p:nvSpPr>
+          <p:cNvPr id="3" name="Content Placeholder 2"/>
+          <p:cNvSpPr>
+            <a:spLocks noGrp="1"/>
+          </p:cNvSpPr>
+          <p:nvPr>
+            <p:ph idx="1"/>
+          </p:nvPr>
+        </p:nvSpPr>
+        <p:spPr/>
+        <p:txBody>
+          <a:bodyPr/>
+          <a:lstStyle/>
+          <a:p>
+            <a:pPr lvl="0"/>
+            <a:r>
+              <a:rPr lang="en-US" smtClean="0"/>
+              <a:t>Click to edit Master text styles</a:t>
+            </a:r>
+          </a:p>
+          <a:p>
+            <a:pPr lvl="1"/>
+            <a:r>
+              <a:rPr lang="en-US" smtClean="0"/>
+              <a:t>Second level</a:t>
+            </a:r>
+          </a:p>
+          <a:p>
+            <a:pPr lvl="2"/>
+            <a:r>
+              <a:rPr lang="en-US" smtClean="0"/>
+              <a:t>Third level</a:t>
+            </a:r>
+          </a:p>
+          <a:p>
+            <a:pPr lvl="3"/>
+            <a:r>
+              <a:rPr lang="en-US" smtClean="0"/>
+              <a:t>Fourth level</a:t>
+            </a:r>
+          </a:p>
+          <a:p>
+            <a:pPr lvl="4"/>
+            <a:r>
+              <a:rPr lang="en-US" smtClean="0"/>
+              <a:t>Fifth level</a:t>
+            </a:r>
+            <a:endParaRPr lang="en-US"/>
+          </a:p>
+        </p:txBody>
+      </p:sp>
+      <p:sp>
+        <p:nvSpPr>
+          <p:cNvPr id="4" name="Date Placeholder 3"/>
+          <p:cNvSpPr>
+            <a:spLocks noGrp="1"/>
+          </p:cNvSpPr>
+          <p:nvPr>
+            <p:ph type="dt" sz="half" idx="10"/>
+          </p:nvPr>
+        </p:nvSpPr>
+        <p:spPr/>
+        <p:txBody>
+          <a:bodyPr/>
+          <a:lstStyle/>
+          <a:p>
+            <a:fld id="{45253105-6222-E44C-A3C9-B345BB2DB333}" type="datetimeFigureOut">
+              <a:rPr lang="en-US" smtClean="0"/>
+              <a:pPr/>
+              <a:t>6/20/14</a:t>
+            </a:fld>
+            <a:endParaRPr lang="en-US"/>
+          </a:p>
+        </p:txBody>
+      </p:sp>
+      <p:sp>
+        <p:nvSpPr>
+          <p:cNvPr id="5" name="Footer Placeholder 4"/>
+          <p:cNvSpPr>
+            <a:spLocks noGrp="1"/>
+          </p:cNvSpPr>
+          <p:nvPr>
+            <p:ph type="ftr" sz="quarter" idx="11"/>
+          </p:nvPr>
+        </p:nvSpPr>
+        <p:spPr/>
+        <p:txBody>
+          <a:bodyPr/>
+          <a:lstStyle/>
+          <a:p>
+            <a:endParaRPr lang="en-US"/>
+          </a:p>
+        </p:txBody>
+      </p:sp>
+      <p:sp>
+        <p:nvSpPr>
+          <p:cNvPr id="6" name="Slide Number Placeholder 5"/>
+          <p:cNvSpPr>
+            <a:spLocks noGrp="1"/>
+          </p:cNvSpPr>
+          <p:nvPr>
+            <p:ph type="sldNum" sz="quarter" idx="12"/>
+          </p:nvPr>
+        </p:nvSpPr>
+        <p:spPr/>
+        <p:txBody>
+          <a:bodyPr/>
+          <a:lstStyle/>
+          <a:p>
+            <a:fld id="{A399DE09-9C7D-4B4C-A05E-F50BAD98C8AA}" type="slidenum">
+              <a:rPr lang="en-US" smtClean="0"/>
+              <a:pPr/>
+              <a:t>‹#›</a:t>
+            </a:fld>
+            <a:endParaRPr lang="en-US"/>
+          </a:p>
+        </p:txBody>
+      </p:sp>
+    </p:spTree>
+  </p:cSld>
+  <p:clrMapOvr>
+    <a:masterClrMapping/>
+  </p:clrMapOvr>
+</p:sldLayout>
+</file>
+
+<file path=ppt/slideLayouts/slideLayout3.xml><?xml version="1.0" encoding="utf-8"?>
+<p:sldLayout xmlns:a="http://schemas.openxmlformats.org/drawingml/2006/main" xmlns:r="http://schemas.openxmlformats.org/officeDocument/2006/relationships" xmlns:mc="http://schemas.openxmlformats.org/markup-compatibility/2006" xmlns:mv="urn:schemas-microsoft-com:mac:vml" xmlns:p="http://schemas.openxmlformats.org/presentationml/2006/main" mc:Ignorable="mv" mc:PreserveAttributes="mv:*" type="secHead" preserve="1">
+  <p:cSld name="Section Header">
+    <p:spTree>
+      <p:nvGrpSpPr>
+        <p:cNvPr id="1" name=""/>
+        <p:cNvGrpSpPr/>
+        <p:nvPr/>
+      </p:nvGrpSpPr>
+      <p:grpSpPr>
+        <a:xfrm>
+          <a:off x="0" y="0"/>
+          <a:ext cx="0" cy="0"/>
+          <a:chOff x="0" y="0"/>
+          <a:chExt cx="0" cy="0"/>
+        </a:xfrm>
+      </p:grpSpPr>
+      <p:sp>
+        <p:nvSpPr>
+          <p:cNvPr id="2" name="Title 1"/>
+          <p:cNvSpPr>
+            <a:spLocks noGrp="1"/>
+          </p:cNvSpPr>
+          <p:nvPr>
+            <p:ph type="title"/>
+          </p:nvPr>
+        </p:nvSpPr>
+        <p:spPr>
+          <a:xfrm>
+            <a:off x="722313" y="4406902"/>
+            <a:ext cx="7772400" cy="1362075"/>
+          </a:xfrm>
+        </p:spPr>
+        <p:txBody>
+          <a:bodyPr anchor="t"/>
+          <a:lstStyle>
+            <a:lvl1pPr algn="l">
+              <a:defRPr sz="4000" b="1" cap="all"/>
+            </a:lvl1pPr>
+          </a:lstStyle>
+          <a:p>
+            <a:r>
+              <a:rPr lang="en-US" smtClean="0"/>
+              <a:t>Click to edit Master title style</a:t>
+            </a:r>
+            <a:endParaRPr lang="en-US"/>
+          </a:p>
+        </p:txBody>
+      </p:sp>
+      <p:sp>
+        <p:nvSpPr>
+          <p:cNvPr id="3" name="Text Placeholder 2"/>
+          <p:cNvSpPr>
+            <a:spLocks noGrp="1"/>
+          </p:cNvSpPr>
+          <p:nvPr>
+            <p:ph type="body" idx="1"/>
+          </p:nvPr>
+        </p:nvSpPr>
+        <p:spPr>
+          <a:xfrm>
+            <a:off x="722313" y="2906713"/>
+            <a:ext cx="7772400" cy="1500187"/>
+          </a:xfrm>
+        </p:spPr>
+        <p:txBody>
+          <a:bodyPr anchor="b"/>
+          <a:lstStyle>
+            <a:lvl1pPr marL="0" indent="0">
+              <a:buNone/>
+              <a:defRPr sz="2000">
+                <a:solidFill>
+                  <a:schemeClr val="tx1">
+                    <a:tint val="75000"/>
+                  </a:schemeClr>
+                </a:solidFill>
+              </a:defRPr>
+            </a:lvl1pPr>
+            <a:lvl2pPr marL="457200" indent="0">
+              <a:buNone/>
+              <a:defRPr sz="1800">
+                <a:solidFill>
+                  <a:schemeClr val="tx1">
+                    <a:tint val="75000"/>
+                  </a:schemeClr>
+                </a:solidFill>
+              </a:defRPr>
+            </a:lvl2pPr>
+            <a:lvl3pPr marL="914400" indent="0">
+              <a:buNone/>
+              <a:defRPr sz="1600">
+                <a:solidFill>
+                  <a:schemeClr val="tx1">
+                    <a:tint val="75000"/>
+                  </a:schemeClr>
+                </a:solidFill>
+              </a:defRPr>
+            </a:lvl3pPr>
+            <a:lvl4pPr marL="1371600" indent="0">
+              <a:buNone/>
+              <a:defRPr sz="1400">
+                <a:solidFill>
+                  <a:schemeClr val="tx1">
+                    <a:tint val="75000"/>
+                  </a:schemeClr>
+                </a:solidFill>
+              </a:defRPr>
+            </a:lvl4pPr>
+            <a:lvl5pPr marL="1828800" indent="0">
+              <a:buNone/>
+              <a:defRPr sz="1400">
+                <a:solidFill>
+                  <a:schemeClr val="tx1">
+                    <a:tint val="75000"/>
+                  </a:schemeClr>
+                </a:solidFill>
+              </a:defRPr>
+            </a:lvl5pPr>
+            <a:lvl6pPr marL="2286000" indent="0">
+              <a:buNone/>
+              <a:defRPr sz="1400">
+                <a:solidFill>
+                  <a:schemeClr val="tx1">
+                    <a:tint val="75000"/>
+                  </a:schemeClr>
+                </a:solidFill>
+              </a:defRPr>
+            </a:lvl6pPr>
+            <a:lvl7pPr marL="2743200" indent="0">
+              <a:buNone/>
+              <a:defRPr sz="1400">
+                <a:solidFill>
+                  <a:schemeClr val="tx1">
+                    <a:tint val="75000"/>
+                  </a:schemeClr>
+                </a:solidFill>
+              </a:defRPr>
+            </a:lvl7pPr>
+            <a:lvl8pPr marL="3200400" indent="0">
+              <a:buNone/>
+              <a:defRPr sz="1400">
+                <a:solidFill>
+                  <a:schemeClr val="tx1">
+                    <a:tint val="75000"/>
+                  </a:schemeClr>
+                </a:solidFill>
+              </a:defRPr>
+            </a:lvl8pPr>
+            <a:lvl9pPr marL="3657600" indent="0">
+              <a:buNone/>
+              <a:defRPr sz="1400">
+                <a:solidFill>
+                  <a:schemeClr val="tx1">
+                    <a:tint val="75000"/>
+                  </a:schemeClr>
+                </a:solidFill>
+              </a:defRPr>
+            </a:lvl9pPr>
+          </a:lstStyle>
+          <a:p>
+            <a:pPr lvl="0"/>
+            <a:r>
+              <a:rPr lang="en-US" smtClean="0"/>
+              <a:t>Click to edit Master text styles</a:t>
+            </a:r>
+          </a:p>
+        </p:txBody>
+      </p:sp>
+      <p:sp>
+        <p:nvSpPr>
+          <p:cNvPr id="4" name="Date Placeholder 3"/>
+          <p:cNvSpPr>
+            <a:spLocks noGrp="1"/>
+          </p:cNvSpPr>
+          <p:nvPr>
+            <p:ph type="dt" sz="half" idx="10"/>
+          </p:nvPr>
+        </p:nvSpPr>
+        <p:spPr/>
+        <p:txBody>
+          <a:bodyPr/>
+          <a:lstStyle/>
+          <a:p>
+            <a:fld id="{45253105-6222-E44C-A3C9-B345BB2DB333}" type="datetimeFigureOut">
+              <a:rPr lang="en-US" smtClean="0"/>
+              <a:pPr/>
+              <a:t>6/20/14</a:t>
+            </a:fld>
+            <a:endParaRPr lang="en-US"/>
+          </a:p>
+        </p:txBody>
+      </p:sp>
+      <p:sp>
+        <p:nvSpPr>
+          <p:cNvPr id="5" name="Footer Placeholder 4"/>
+          <p:cNvSpPr>
+            <a:spLocks noGrp="1"/>
+          </p:cNvSpPr>
+          <p:nvPr>
+            <p:ph type="ftr" sz="quarter" idx="11"/>
+          </p:nvPr>
+        </p:nvSpPr>
+        <p:spPr/>
+        <p:txBody>
+          <a:bodyPr/>
+          <a:lstStyle/>
+          <a:p>
+            <a:endParaRPr lang="en-US"/>
+          </a:p>
+        </p:txBody>
+      </p:sp>
+      <p:sp>
+        <p:nvSpPr>
+          <p:cNvPr id="6" name="Slide Number Placeholder 5"/>
+          <p:cNvSpPr>
+            <a:spLocks noGrp="1"/>
+          </p:cNvSpPr>
+          <p:nvPr>
+            <p:ph type="sldNum" sz="quarter" idx="12"/>
+          </p:nvPr>
+        </p:nvSpPr>
+        <p:spPr/>
+        <p:txBody>
+          <a:bodyPr/>
+          <a:lstStyle/>
+          <a:p>
+            <a:fld id="{A399DE09-9C7D-4B4C-A05E-F50BAD98C8AA}" type="slidenum">
+              <a:rPr lang="en-US" smtClean="0"/>
+              <a:pPr/>
+              <a:t>‹#›</a:t>
+            </a:fld>
+            <a:endParaRPr lang="en-US"/>
+          </a:p>
+        </p:txBody>
+      </p:sp>
+    </p:spTree>
+  </p:cSld>
+  <p:clrMapOvr>
+    <a:masterClrMapping/>
+  </p:clrMapOvr>
+</p:sldLayout>
+</file>
+
 <file path=ppt/slideLayouts/slideLayout4.xml><?xml version="1.0" encoding="utf-8"?>
 <p:sldLayout xmlns:a="http://schemas.openxmlformats.org/drawingml/2006/main" xmlns:r="http://schemas.openxmlformats.org/officeDocument/2006/relationships" xmlns:mc="http://schemas.openxmlformats.org/markup-compatibility/2006" xmlns:mv="urn:schemas-microsoft-com:mac:vml" xmlns:p="http://schemas.openxmlformats.org/presentationml/2006/main" mc:Ignorable="mv" mc:PreserveAttributes="mv:*" type="twoObj" preserve="1">
   <p:cSld name="Two Content">
@@ -766,6 +1995,425 @@
       <p:sp>
         <p:nvSpPr>
           <p:cNvPr id="7" name="Slide Number Placeholder 6"/>
+          <p:cNvSpPr>
+            <a:spLocks noGrp="1"/>
+          </p:cNvSpPr>
+          <p:nvPr>
+            <p:ph type="sldNum" sz="quarter" idx="12"/>
+          </p:nvPr>
+        </p:nvSpPr>
+        <p:spPr/>
+        <p:txBody>
+          <a:bodyPr/>
+          <a:lstStyle/>
+          <a:p>
+            <a:fld id="{A399DE09-9C7D-4B4C-A05E-F50BAD98C8AA}" type="slidenum">
+              <a:rPr lang="en-US" smtClean="0"/>
+              <a:pPr/>
+              <a:t>‹#›</a:t>
+            </a:fld>
+            <a:endParaRPr lang="en-US"/>
+          </a:p>
+        </p:txBody>
+      </p:sp>
+    </p:spTree>
+  </p:cSld>
+  <p:clrMapOvr>
+    <a:masterClrMapping/>
+  </p:clrMapOvr>
+</p:sldLayout>
+</file>
+
+<file path=ppt/slideLayouts/slideLayout5.xml><?xml version="1.0" encoding="utf-8"?>
+<p:sldLayout xmlns:a="http://schemas.openxmlformats.org/drawingml/2006/main" xmlns:r="http://schemas.openxmlformats.org/officeDocument/2006/relationships" xmlns:mc="http://schemas.openxmlformats.org/markup-compatibility/2006" xmlns:mv="urn:schemas-microsoft-com:mac:vml" xmlns:p="http://schemas.openxmlformats.org/presentationml/2006/main" mc:Ignorable="mv" mc:PreserveAttributes="mv:*" type="twoTxTwoObj" preserve="1">
+  <p:cSld name="Comparison">
+    <p:spTree>
+      <p:nvGrpSpPr>
+        <p:cNvPr id="1" name=""/>
+        <p:cNvGrpSpPr/>
+        <p:nvPr/>
+      </p:nvGrpSpPr>
+      <p:grpSpPr>
+        <a:xfrm>
+          <a:off x="0" y="0"/>
+          <a:ext cx="0" cy="0"/>
+          <a:chOff x="0" y="0"/>
+          <a:chExt cx="0" cy="0"/>
+        </a:xfrm>
+      </p:grpSpPr>
+      <p:sp>
+        <p:nvSpPr>
+          <p:cNvPr id="2" name="Title 1"/>
+          <p:cNvSpPr>
+            <a:spLocks noGrp="1"/>
+          </p:cNvSpPr>
+          <p:nvPr>
+            <p:ph type="title"/>
+          </p:nvPr>
+        </p:nvSpPr>
+        <p:spPr/>
+        <p:txBody>
+          <a:bodyPr/>
+          <a:lstStyle>
+            <a:lvl1pPr>
+              <a:defRPr/>
+            </a:lvl1pPr>
+          </a:lstStyle>
+          <a:p>
+            <a:r>
+              <a:rPr lang="en-US" smtClean="0"/>
+              <a:t>Click to edit Master title style</a:t>
+            </a:r>
+            <a:endParaRPr lang="en-US"/>
+          </a:p>
+        </p:txBody>
+      </p:sp>
+      <p:sp>
+        <p:nvSpPr>
+          <p:cNvPr id="3" name="Text Placeholder 2"/>
+          <p:cNvSpPr>
+            <a:spLocks noGrp="1"/>
+          </p:cNvSpPr>
+          <p:nvPr>
+            <p:ph type="body" idx="1"/>
+          </p:nvPr>
+        </p:nvSpPr>
+        <p:spPr>
+          <a:xfrm>
+            <a:off x="457200" y="1535113"/>
+            <a:ext cx="4040188" cy="639762"/>
+          </a:xfrm>
+        </p:spPr>
+        <p:txBody>
+          <a:bodyPr anchor="b"/>
+          <a:lstStyle>
+            <a:lvl1pPr marL="0" indent="0">
+              <a:buNone/>
+              <a:defRPr sz="2400" b="1"/>
+            </a:lvl1pPr>
+            <a:lvl2pPr marL="457200" indent="0">
+              <a:buNone/>
+              <a:defRPr sz="2000" b="1"/>
+            </a:lvl2pPr>
+            <a:lvl3pPr marL="914400" indent="0">
+              <a:buNone/>
+              <a:defRPr sz="1800" b="1"/>
+            </a:lvl3pPr>
+            <a:lvl4pPr marL="1371600" indent="0">
+              <a:buNone/>
+              <a:defRPr sz="1600" b="1"/>
+            </a:lvl4pPr>
+            <a:lvl5pPr marL="1828800" indent="0">
+              <a:buNone/>
+              <a:defRPr sz="1600" b="1"/>
+            </a:lvl5pPr>
+            <a:lvl6pPr marL="2286000" indent="0">
+              <a:buNone/>
+              <a:defRPr sz="1600" b="1"/>
+            </a:lvl6pPr>
+            <a:lvl7pPr marL="2743200" indent="0">
+              <a:buNone/>
+              <a:defRPr sz="1600" b="1"/>
+            </a:lvl7pPr>
+            <a:lvl8pPr marL="3200400" indent="0">
+              <a:buNone/>
+              <a:defRPr sz="1600" b="1"/>
+            </a:lvl8pPr>
+            <a:lvl9pPr marL="3657600" indent="0">
+              <a:buNone/>
+              <a:defRPr sz="1600" b="1"/>
+            </a:lvl9pPr>
+          </a:lstStyle>
+          <a:p>
+            <a:pPr lvl="0"/>
+            <a:r>
+              <a:rPr lang="en-US" smtClean="0"/>
+              <a:t>Click to edit Master text styles</a:t>
+            </a:r>
+          </a:p>
+        </p:txBody>
+      </p:sp>
+      <p:sp>
+        <p:nvSpPr>
+          <p:cNvPr id="4" name="Content Placeholder 3"/>
+          <p:cNvSpPr>
+            <a:spLocks noGrp="1"/>
+          </p:cNvSpPr>
+          <p:nvPr>
+            <p:ph sz="half" idx="2"/>
+          </p:nvPr>
+        </p:nvSpPr>
+        <p:spPr>
+          <a:xfrm>
+            <a:off x="457200" y="2174875"/>
+            <a:ext cx="4040188" cy="3951288"/>
+          </a:xfrm>
+        </p:spPr>
+        <p:txBody>
+          <a:bodyPr/>
+          <a:lstStyle>
+            <a:lvl1pPr>
+              <a:defRPr sz="2400"/>
+            </a:lvl1pPr>
+            <a:lvl2pPr>
+              <a:defRPr sz="2000"/>
+            </a:lvl2pPr>
+            <a:lvl3pPr>
+              <a:defRPr sz="1800"/>
+            </a:lvl3pPr>
+            <a:lvl4pPr>
+              <a:defRPr sz="1600"/>
+            </a:lvl4pPr>
+            <a:lvl5pPr>
+              <a:defRPr sz="1600"/>
+            </a:lvl5pPr>
+            <a:lvl6pPr>
+              <a:defRPr sz="1600"/>
+            </a:lvl6pPr>
+            <a:lvl7pPr>
+              <a:defRPr sz="1600"/>
+            </a:lvl7pPr>
+            <a:lvl8pPr>
+              <a:defRPr sz="1600"/>
+            </a:lvl8pPr>
+            <a:lvl9pPr>
+              <a:defRPr sz="1600"/>
+            </a:lvl9pPr>
+          </a:lstStyle>
+          <a:p>
+            <a:pPr lvl="0"/>
+            <a:r>
+              <a:rPr lang="en-US" smtClean="0"/>
+              <a:t>Click to edit Master text styles</a:t>
+            </a:r>
+          </a:p>
+          <a:p>
+            <a:pPr lvl="1"/>
+            <a:r>
+              <a:rPr lang="en-US" smtClean="0"/>
+              <a:t>Second level</a:t>
+            </a:r>
+          </a:p>
+          <a:p>
+            <a:pPr lvl="2"/>
+            <a:r>
+              <a:rPr lang="en-US" smtClean="0"/>
+              <a:t>Third level</a:t>
+            </a:r>
+          </a:p>
+          <a:p>
+            <a:pPr lvl="3"/>
+            <a:r>
+              <a:rPr lang="en-US" smtClean="0"/>
+              <a:t>Fourth level</a:t>
+            </a:r>
+          </a:p>
+          <a:p>
+            <a:pPr lvl="4"/>
+            <a:r>
+              <a:rPr lang="en-US" smtClean="0"/>
+              <a:t>Fifth level</a:t>
+            </a:r>
+            <a:endParaRPr lang="en-US"/>
+          </a:p>
+        </p:txBody>
+      </p:sp>
+      <p:sp>
+        <p:nvSpPr>
+          <p:cNvPr id="5" name="Text Placeholder 4"/>
+          <p:cNvSpPr>
+            <a:spLocks noGrp="1"/>
+          </p:cNvSpPr>
+          <p:nvPr>
+            <p:ph type="body" sz="quarter" idx="3"/>
+          </p:nvPr>
+        </p:nvSpPr>
+        <p:spPr>
+          <a:xfrm>
+            <a:off x="4645026" y="1535113"/>
+            <a:ext cx="4041775" cy="639762"/>
+          </a:xfrm>
+        </p:spPr>
+        <p:txBody>
+          <a:bodyPr anchor="b"/>
+          <a:lstStyle>
+            <a:lvl1pPr marL="0" indent="0">
+              <a:buNone/>
+              <a:defRPr sz="2400" b="1"/>
+            </a:lvl1pPr>
+            <a:lvl2pPr marL="457200" indent="0">
+              <a:buNone/>
+              <a:defRPr sz="2000" b="1"/>
+            </a:lvl2pPr>
+            <a:lvl3pPr marL="914400" indent="0">
+              <a:buNone/>
+              <a:defRPr sz="1800" b="1"/>
+            </a:lvl3pPr>
+            <a:lvl4pPr marL="1371600" indent="0">
+              <a:buNone/>
+              <a:defRPr sz="1600" b="1"/>
+            </a:lvl4pPr>
+            <a:lvl5pPr marL="1828800" indent="0">
+              <a:buNone/>
+              <a:defRPr sz="1600" b="1"/>
+            </a:lvl5pPr>
+            <a:lvl6pPr marL="2286000" indent="0">
+              <a:buNone/>
+              <a:defRPr sz="1600" b="1"/>
+            </a:lvl6pPr>
+            <a:lvl7pPr marL="2743200" indent="0">
+              <a:buNone/>
+              <a:defRPr sz="1600" b="1"/>
+            </a:lvl7pPr>
+            <a:lvl8pPr marL="3200400" indent="0">
+              <a:buNone/>
+              <a:defRPr sz="1600" b="1"/>
+            </a:lvl8pPr>
+            <a:lvl9pPr marL="3657600" indent="0">
+              <a:buNone/>
+              <a:defRPr sz="1600" b="1"/>
+            </a:lvl9pPr>
+          </a:lstStyle>
+          <a:p>
+            <a:pPr lvl="0"/>
+            <a:r>
+              <a:rPr lang="en-US" smtClean="0"/>
+              <a:t>Click to edit Master text styles</a:t>
+            </a:r>
+          </a:p>
+        </p:txBody>
+      </p:sp>
+      <p:sp>
+        <p:nvSpPr>
+          <p:cNvPr id="6" name="Content Placeholder 5"/>
+          <p:cNvSpPr>
+            <a:spLocks noGrp="1"/>
+          </p:cNvSpPr>
+          <p:nvPr>
+            <p:ph sz="quarter" idx="4"/>
+          </p:nvPr>
+        </p:nvSpPr>
+        <p:spPr>
+          <a:xfrm>
+            <a:off x="4645026" y="2174875"/>
+            <a:ext cx="4041775" cy="3951288"/>
+          </a:xfrm>
+        </p:spPr>
+        <p:txBody>
+          <a:bodyPr/>
+          <a:lstStyle>
+            <a:lvl1pPr>
+              <a:defRPr sz="2400"/>
+            </a:lvl1pPr>
+            <a:lvl2pPr>
+              <a:defRPr sz="2000"/>
+            </a:lvl2pPr>
+            <a:lvl3pPr>
+              <a:defRPr sz="1800"/>
+            </a:lvl3pPr>
+            <a:lvl4pPr>
+              <a:defRPr sz="1600"/>
+            </a:lvl4pPr>
+            <a:lvl5pPr>
+              <a:defRPr sz="1600"/>
+            </a:lvl5pPr>
+            <a:lvl6pPr>
+              <a:defRPr sz="1600"/>
+            </a:lvl6pPr>
+            <a:lvl7pPr>
+              <a:defRPr sz="1600"/>
+            </a:lvl7pPr>
+            <a:lvl8pPr>
+              <a:defRPr sz="1600"/>
+            </a:lvl8pPr>
+            <a:lvl9pPr>
+              <a:defRPr sz="1600"/>
+            </a:lvl9pPr>
+          </a:lstStyle>
+          <a:p>
+            <a:pPr lvl="0"/>
+            <a:r>
+              <a:rPr lang="en-US" smtClean="0"/>
+              <a:t>Click to edit Master text styles</a:t>
+            </a:r>
+          </a:p>
+          <a:p>
+            <a:pPr lvl="1"/>
+            <a:r>
+              <a:rPr lang="en-US" smtClean="0"/>
+              <a:t>Second level</a:t>
+            </a:r>
+          </a:p>
+          <a:p>
+            <a:pPr lvl="2"/>
+            <a:r>
+              <a:rPr lang="en-US" smtClean="0"/>
+              <a:t>Third level</a:t>
+            </a:r>
+          </a:p>
+          <a:p>
+            <a:pPr lvl="3"/>
+            <a:r>
+              <a:rPr lang="en-US" smtClean="0"/>
+              <a:t>Fourth level</a:t>
+            </a:r>
+          </a:p>
+          <a:p>
+            <a:pPr lvl="4"/>
+            <a:r>
+              <a:rPr lang="en-US" smtClean="0"/>
+              <a:t>Fifth level</a:t>
+            </a:r>
+            <a:endParaRPr lang="en-US"/>
+          </a:p>
+        </p:txBody>
+      </p:sp>
+      <p:sp>
+        <p:nvSpPr>
+          <p:cNvPr id="7" name="Date Placeholder 6"/>
+          <p:cNvSpPr>
+            <a:spLocks noGrp="1"/>
+          </p:cNvSpPr>
+          <p:nvPr>
+            <p:ph type="dt" sz="half" idx="10"/>
+          </p:nvPr>
+        </p:nvSpPr>
+        <p:spPr/>
+        <p:txBody>
+          <a:bodyPr/>
+          <a:lstStyle/>
+          <a:p>
+            <a:fld id="{45253105-6222-E44C-A3C9-B345BB2DB333}" type="datetimeFigureOut">
+              <a:rPr lang="en-US" smtClean="0"/>
+              <a:pPr/>
+              <a:t>6/20/14</a:t>
+            </a:fld>
+            <a:endParaRPr lang="en-US"/>
+          </a:p>
+        </p:txBody>
+      </p:sp>
+      <p:sp>
+        <p:nvSpPr>
+          <p:cNvPr id="8" name="Footer Placeholder 7"/>
+          <p:cNvSpPr>
+            <a:spLocks noGrp="1"/>
+          </p:cNvSpPr>
+          <p:nvPr>
+            <p:ph type="ftr" sz="quarter" idx="11"/>
+          </p:nvPr>
+        </p:nvSpPr>
+        <p:spPr/>
+        <p:txBody>
+          <a:bodyPr/>
+          <a:lstStyle/>
+          <a:p>
+            <a:endParaRPr lang="en-US"/>
+          </a:p>
+        </p:txBody>
+      </p:sp>
+      <p:sp>
+        <p:nvSpPr>
+          <p:cNvPr id="9" name="Slide Number Placeholder 8"/>
           <p:cNvSpPr>
             <a:spLocks noGrp="1"/>
           </p:cNvSpPr>
@@ -1274,6 +2922,2645 @@
     <a:masterClrMapping/>
   </p:clrMapOvr>
 </p:sldLayout>
+</file>
+
+<file path=ppt/slideLayouts/slideLayout9.xml><?xml version="1.0" encoding="utf-8"?>
+<p:sldLayout xmlns:a="http://schemas.openxmlformats.org/drawingml/2006/main" xmlns:r="http://schemas.openxmlformats.org/officeDocument/2006/relationships" xmlns:mc="http://schemas.openxmlformats.org/markup-compatibility/2006" xmlns:mv="urn:schemas-microsoft-com:mac:vml" xmlns:p="http://schemas.openxmlformats.org/presentationml/2006/main" mc:Ignorable="mv" mc:PreserveAttributes="mv:*" type="picTx" preserve="1">
+  <p:cSld name="Picture with Caption">
+    <p:spTree>
+      <p:nvGrpSpPr>
+        <p:cNvPr id="1" name=""/>
+        <p:cNvGrpSpPr/>
+        <p:nvPr/>
+      </p:nvGrpSpPr>
+      <p:grpSpPr>
+        <a:xfrm>
+          <a:off x="0" y="0"/>
+          <a:ext cx="0" cy="0"/>
+          <a:chOff x="0" y="0"/>
+          <a:chExt cx="0" cy="0"/>
+        </a:xfrm>
+      </p:grpSpPr>
+      <p:sp>
+        <p:nvSpPr>
+          <p:cNvPr id="2" name="Title 1"/>
+          <p:cNvSpPr>
+            <a:spLocks noGrp="1"/>
+          </p:cNvSpPr>
+          <p:nvPr>
+            <p:ph type="title"/>
+          </p:nvPr>
+        </p:nvSpPr>
+        <p:spPr>
+          <a:xfrm>
+            <a:off x="1792288" y="4800600"/>
+            <a:ext cx="5486400" cy="566738"/>
+          </a:xfrm>
+        </p:spPr>
+        <p:txBody>
+          <a:bodyPr anchor="b"/>
+          <a:lstStyle>
+            <a:lvl1pPr algn="l">
+              <a:defRPr sz="2000" b="1"/>
+            </a:lvl1pPr>
+          </a:lstStyle>
+          <a:p>
+            <a:r>
+              <a:rPr lang="en-US" smtClean="0"/>
+              <a:t>Click to edit Master title style</a:t>
+            </a:r>
+            <a:endParaRPr lang="en-US"/>
+          </a:p>
+        </p:txBody>
+      </p:sp>
+      <p:sp>
+        <p:nvSpPr>
+          <p:cNvPr id="3" name="Picture Placeholder 2"/>
+          <p:cNvSpPr>
+            <a:spLocks noGrp="1"/>
+          </p:cNvSpPr>
+          <p:nvPr>
+            <p:ph type="pic" idx="1"/>
+          </p:nvPr>
+        </p:nvSpPr>
+        <p:spPr>
+          <a:xfrm>
+            <a:off x="1792288" y="612775"/>
+            <a:ext cx="5486400" cy="4114800"/>
+          </a:xfrm>
+        </p:spPr>
+        <p:txBody>
+          <a:bodyPr/>
+          <a:lstStyle>
+            <a:lvl1pPr marL="0" indent="0">
+              <a:buNone/>
+              <a:defRPr sz="3200"/>
+            </a:lvl1pPr>
+            <a:lvl2pPr marL="457200" indent="0">
+              <a:buNone/>
+              <a:defRPr sz="2800"/>
+            </a:lvl2pPr>
+            <a:lvl3pPr marL="914400" indent="0">
+              <a:buNone/>
+              <a:defRPr sz="2400"/>
+            </a:lvl3pPr>
+            <a:lvl4pPr marL="1371600" indent="0">
+              <a:buNone/>
+              <a:defRPr sz="2000"/>
+            </a:lvl4pPr>
+            <a:lvl5pPr marL="1828800" indent="0">
+              <a:buNone/>
+              <a:defRPr sz="2000"/>
+            </a:lvl5pPr>
+            <a:lvl6pPr marL="2286000" indent="0">
+              <a:buNone/>
+              <a:defRPr sz="2000"/>
+            </a:lvl6pPr>
+            <a:lvl7pPr marL="2743200" indent="0">
+              <a:buNone/>
+              <a:defRPr sz="2000"/>
+            </a:lvl7pPr>
+            <a:lvl8pPr marL="3200400" indent="0">
+              <a:buNone/>
+              <a:defRPr sz="2000"/>
+            </a:lvl8pPr>
+            <a:lvl9pPr marL="3657600" indent="0">
+              <a:buNone/>
+              <a:defRPr sz="2000"/>
+            </a:lvl9pPr>
+          </a:lstStyle>
+          <a:p>
+            <a:endParaRPr lang="en-US"/>
+          </a:p>
+        </p:txBody>
+      </p:sp>
+      <p:sp>
+        <p:nvSpPr>
+          <p:cNvPr id="4" name="Text Placeholder 3"/>
+          <p:cNvSpPr>
+            <a:spLocks noGrp="1"/>
+          </p:cNvSpPr>
+          <p:nvPr>
+            <p:ph type="body" sz="half" idx="2"/>
+          </p:nvPr>
+        </p:nvSpPr>
+        <p:spPr>
+          <a:xfrm>
+            <a:off x="1792288" y="5367338"/>
+            <a:ext cx="5486400" cy="804862"/>
+          </a:xfrm>
+        </p:spPr>
+        <p:txBody>
+          <a:bodyPr/>
+          <a:lstStyle>
+            <a:lvl1pPr marL="0" indent="0">
+              <a:buNone/>
+              <a:defRPr sz="1400"/>
+            </a:lvl1pPr>
+            <a:lvl2pPr marL="457200" indent="0">
+              <a:buNone/>
+              <a:defRPr sz="1200"/>
+            </a:lvl2pPr>
+            <a:lvl3pPr marL="914400" indent="0">
+              <a:buNone/>
+              <a:defRPr sz="1000"/>
+            </a:lvl3pPr>
+            <a:lvl4pPr marL="1371600" indent="0">
+              <a:buNone/>
+              <a:defRPr sz="900"/>
+            </a:lvl4pPr>
+            <a:lvl5pPr marL="1828800" indent="0">
+              <a:buNone/>
+              <a:defRPr sz="900"/>
+            </a:lvl5pPr>
+            <a:lvl6pPr marL="2286000" indent="0">
+              <a:buNone/>
+              <a:defRPr sz="900"/>
+            </a:lvl6pPr>
+            <a:lvl7pPr marL="2743200" indent="0">
+              <a:buNone/>
+              <a:defRPr sz="900"/>
+            </a:lvl7pPr>
+            <a:lvl8pPr marL="3200400" indent="0">
+              <a:buNone/>
+              <a:defRPr sz="900"/>
+            </a:lvl8pPr>
+            <a:lvl9pPr marL="3657600" indent="0">
+              <a:buNone/>
+              <a:defRPr sz="900"/>
+            </a:lvl9pPr>
+          </a:lstStyle>
+          <a:p>
+            <a:pPr lvl="0"/>
+            <a:r>
+              <a:rPr lang="en-US" smtClean="0"/>
+              <a:t>Click to edit Master text styles</a:t>
+            </a:r>
+          </a:p>
+        </p:txBody>
+      </p:sp>
+      <p:sp>
+        <p:nvSpPr>
+          <p:cNvPr id="5" name="Date Placeholder 4"/>
+          <p:cNvSpPr>
+            <a:spLocks noGrp="1"/>
+          </p:cNvSpPr>
+          <p:nvPr>
+            <p:ph type="dt" sz="half" idx="10"/>
+          </p:nvPr>
+        </p:nvSpPr>
+        <p:spPr/>
+        <p:txBody>
+          <a:bodyPr/>
+          <a:lstStyle/>
+          <a:p>
+            <a:fld id="{45253105-6222-E44C-A3C9-B345BB2DB333}" type="datetimeFigureOut">
+              <a:rPr lang="en-US" smtClean="0"/>
+              <a:pPr/>
+              <a:t>6/20/14</a:t>
+            </a:fld>
+            <a:endParaRPr lang="en-US"/>
+          </a:p>
+        </p:txBody>
+      </p:sp>
+      <p:sp>
+        <p:nvSpPr>
+          <p:cNvPr id="6" name="Footer Placeholder 5"/>
+          <p:cNvSpPr>
+            <a:spLocks noGrp="1"/>
+          </p:cNvSpPr>
+          <p:nvPr>
+            <p:ph type="ftr" sz="quarter" idx="11"/>
+          </p:nvPr>
+        </p:nvSpPr>
+        <p:spPr/>
+        <p:txBody>
+          <a:bodyPr/>
+          <a:lstStyle/>
+          <a:p>
+            <a:endParaRPr lang="en-US"/>
+          </a:p>
+        </p:txBody>
+      </p:sp>
+      <p:sp>
+        <p:nvSpPr>
+          <p:cNvPr id="7" name="Slide Number Placeholder 6"/>
+          <p:cNvSpPr>
+            <a:spLocks noGrp="1"/>
+          </p:cNvSpPr>
+          <p:nvPr>
+            <p:ph type="sldNum" sz="quarter" idx="12"/>
+          </p:nvPr>
+        </p:nvSpPr>
+        <p:spPr/>
+        <p:txBody>
+          <a:bodyPr/>
+          <a:lstStyle/>
+          <a:p>
+            <a:fld id="{A399DE09-9C7D-4B4C-A05E-F50BAD98C8AA}" type="slidenum">
+              <a:rPr lang="en-US" smtClean="0"/>
+              <a:pPr/>
+              <a:t>‹#›</a:t>
+            </a:fld>
+            <a:endParaRPr lang="en-US"/>
+          </a:p>
+        </p:txBody>
+      </p:sp>
+    </p:spTree>
+  </p:cSld>
+  <p:clrMapOvr>
+    <a:masterClrMapping/>
+  </p:clrMapOvr>
+</p:sldLayout>
+</file>
+
+<file path=ppt/slideMasters/slideMaster1.xml><?xml version="1.0" encoding="utf-8"?>
+<p:sldMaster xmlns:a="http://schemas.openxmlformats.org/drawingml/2006/main" xmlns:r="http://schemas.openxmlformats.org/officeDocument/2006/relationships" xmlns:mc="http://schemas.openxmlformats.org/markup-compatibility/2006" xmlns:mv="urn:schemas-microsoft-com:mac:vml" xmlns:p="http://schemas.openxmlformats.org/presentationml/2006/main" mc:Ignorable="mv" mc:PreserveAttributes="mv:*">
+  <p:cSld>
+    <p:bg>
+      <p:bgRef idx="1001">
+        <a:schemeClr val="bg1"/>
+      </p:bgRef>
+    </p:bg>
+    <p:spTree>
+      <p:nvGrpSpPr>
+        <p:cNvPr id="1" name=""/>
+        <p:cNvGrpSpPr/>
+        <p:nvPr/>
+      </p:nvGrpSpPr>
+      <p:grpSpPr>
+        <a:xfrm>
+          <a:off x="0" y="0"/>
+          <a:ext cx="0" cy="0"/>
+          <a:chOff x="0" y="0"/>
+          <a:chExt cx="0" cy="0"/>
+        </a:xfrm>
+      </p:grpSpPr>
+      <p:sp>
+        <p:nvSpPr>
+          <p:cNvPr id="2" name="Title Placeholder 1"/>
+          <p:cNvSpPr>
+            <a:spLocks noGrp="1"/>
+          </p:cNvSpPr>
+          <p:nvPr>
+            <p:ph type="title"/>
+          </p:nvPr>
+        </p:nvSpPr>
+        <p:spPr>
+          <a:xfrm>
+            <a:off x="457200" y="274638"/>
+            <a:ext cx="8229600" cy="1143000"/>
+          </a:xfrm>
+          <a:prstGeom prst="rect">
+            <a:avLst/>
+          </a:prstGeom>
+        </p:spPr>
+        <p:txBody>
+          <a:bodyPr vert="horz" lIns="91440" tIns="45720" rIns="91440" bIns="45720" rtlCol="0" anchor="ctr">
+            <a:normAutofit/>
+          </a:bodyPr>
+          <a:lstStyle/>
+          <a:p>
+            <a:r>
+              <a:rPr lang="en-US" smtClean="0"/>
+              <a:t>Click to edit Master title style</a:t>
+            </a:r>
+            <a:endParaRPr lang="en-US"/>
+          </a:p>
+        </p:txBody>
+      </p:sp>
+      <p:sp>
+        <p:nvSpPr>
+          <p:cNvPr id="3" name="Text Placeholder 2"/>
+          <p:cNvSpPr>
+            <a:spLocks noGrp="1"/>
+          </p:cNvSpPr>
+          <p:nvPr>
+            <p:ph type="body" idx="1"/>
+          </p:nvPr>
+        </p:nvSpPr>
+        <p:spPr>
+          <a:xfrm>
+            <a:off x="457200" y="1600202"/>
+            <a:ext cx="8229600" cy="4525963"/>
+          </a:xfrm>
+          <a:prstGeom prst="rect">
+            <a:avLst/>
+          </a:prstGeom>
+        </p:spPr>
+        <p:txBody>
+          <a:bodyPr vert="horz" lIns="91440" tIns="45720" rIns="91440" bIns="45720" rtlCol="0">
+            <a:normAutofit/>
+          </a:bodyPr>
+          <a:lstStyle/>
+          <a:p>
+            <a:pPr lvl="0"/>
+            <a:r>
+              <a:rPr lang="en-US" smtClean="0"/>
+              <a:t>Click to edit Master text styles</a:t>
+            </a:r>
+          </a:p>
+          <a:p>
+            <a:pPr lvl="1"/>
+            <a:r>
+              <a:rPr lang="en-US" smtClean="0"/>
+              <a:t>Second level</a:t>
+            </a:r>
+          </a:p>
+          <a:p>
+            <a:pPr lvl="2"/>
+            <a:r>
+              <a:rPr lang="en-US" smtClean="0"/>
+              <a:t>Third level</a:t>
+            </a:r>
+          </a:p>
+          <a:p>
+            <a:pPr lvl="3"/>
+            <a:r>
+              <a:rPr lang="en-US" smtClean="0"/>
+              <a:t>Fourth level</a:t>
+            </a:r>
+          </a:p>
+          <a:p>
+            <a:pPr lvl="4"/>
+            <a:r>
+              <a:rPr lang="en-US" smtClean="0"/>
+              <a:t>Fifth level</a:t>
+            </a:r>
+            <a:endParaRPr lang="en-US"/>
+          </a:p>
+        </p:txBody>
+      </p:sp>
+      <p:sp>
+        <p:nvSpPr>
+          <p:cNvPr id="4" name="Date Placeholder 3"/>
+          <p:cNvSpPr>
+            <a:spLocks noGrp="1"/>
+          </p:cNvSpPr>
+          <p:nvPr>
+            <p:ph type="dt" sz="half" idx="2"/>
+          </p:nvPr>
+        </p:nvSpPr>
+        <p:spPr>
+          <a:xfrm>
+            <a:off x="457200" y="6356352"/>
+            <a:ext cx="2133600" cy="365125"/>
+          </a:xfrm>
+          <a:prstGeom prst="rect">
+            <a:avLst/>
+          </a:prstGeom>
+        </p:spPr>
+        <p:txBody>
+          <a:bodyPr vert="horz" lIns="91440" tIns="45720" rIns="91440" bIns="45720" rtlCol="0" anchor="ctr"/>
+          <a:lstStyle>
+            <a:lvl1pPr algn="l">
+              <a:defRPr sz="1200">
+                <a:solidFill>
+                  <a:schemeClr val="tx1">
+                    <a:tint val="75000"/>
+                  </a:schemeClr>
+                </a:solidFill>
+              </a:defRPr>
+            </a:lvl1pPr>
+          </a:lstStyle>
+          <a:p>
+            <a:fld id="{45253105-6222-E44C-A3C9-B345BB2DB333}" type="datetimeFigureOut">
+              <a:rPr lang="en-US" smtClean="0"/>
+              <a:pPr/>
+              <a:t>6/20/14</a:t>
+            </a:fld>
+            <a:endParaRPr lang="en-US"/>
+          </a:p>
+        </p:txBody>
+      </p:sp>
+      <p:sp>
+        <p:nvSpPr>
+          <p:cNvPr id="5" name="Footer Placeholder 4"/>
+          <p:cNvSpPr>
+            <a:spLocks noGrp="1"/>
+          </p:cNvSpPr>
+          <p:nvPr>
+            <p:ph type="ftr" sz="quarter" idx="3"/>
+          </p:nvPr>
+        </p:nvSpPr>
+        <p:spPr>
+          <a:xfrm>
+            <a:off x="3124200" y="6356352"/>
+            <a:ext cx="2895600" cy="365125"/>
+          </a:xfrm>
+          <a:prstGeom prst="rect">
+            <a:avLst/>
+          </a:prstGeom>
+        </p:spPr>
+        <p:txBody>
+          <a:bodyPr vert="horz" lIns="91440" tIns="45720" rIns="91440" bIns="45720" rtlCol="0" anchor="ctr"/>
+          <a:lstStyle>
+            <a:lvl1pPr algn="ctr">
+              <a:defRPr sz="1200">
+                <a:solidFill>
+                  <a:schemeClr val="tx1">
+                    <a:tint val="75000"/>
+                  </a:schemeClr>
+                </a:solidFill>
+              </a:defRPr>
+            </a:lvl1pPr>
+          </a:lstStyle>
+          <a:p>
+            <a:endParaRPr lang="en-US"/>
+          </a:p>
+        </p:txBody>
+      </p:sp>
+      <p:sp>
+        <p:nvSpPr>
+          <p:cNvPr id="6" name="Slide Number Placeholder 5"/>
+          <p:cNvSpPr>
+            <a:spLocks noGrp="1"/>
+          </p:cNvSpPr>
+          <p:nvPr>
+            <p:ph type="sldNum" sz="quarter" idx="4"/>
+          </p:nvPr>
+        </p:nvSpPr>
+        <p:spPr>
+          <a:xfrm>
+            <a:off x="6553200" y="6356352"/>
+            <a:ext cx="2133600" cy="365125"/>
+          </a:xfrm>
+          <a:prstGeom prst="rect">
+            <a:avLst/>
+          </a:prstGeom>
+        </p:spPr>
+        <p:txBody>
+          <a:bodyPr vert="horz" lIns="91440" tIns="45720" rIns="91440" bIns="45720" rtlCol="0" anchor="ctr"/>
+          <a:lstStyle>
+            <a:lvl1pPr algn="r">
+              <a:defRPr sz="1200">
+                <a:solidFill>
+                  <a:schemeClr val="tx1">
+                    <a:tint val="75000"/>
+                  </a:schemeClr>
+                </a:solidFill>
+              </a:defRPr>
+            </a:lvl1pPr>
+          </a:lstStyle>
+          <a:p>
+            <a:fld id="{A399DE09-9C7D-4B4C-A05E-F50BAD98C8AA}" type="slidenum">
+              <a:rPr lang="en-US" smtClean="0"/>
+              <a:pPr/>
+              <a:t>‹#›</a:t>
+            </a:fld>
+            <a:endParaRPr lang="en-US"/>
+          </a:p>
+        </p:txBody>
+      </p:sp>
+    </p:spTree>
+  </p:cSld>
+  <p:clrMap bg1="lt1" tx1="dk1" bg2="lt2" tx2="dk2" accent1="accent1" accent2="accent2" accent3="accent3" accent4="accent4" accent5="accent5" accent6="accent6" hlink="hlink" folHlink="folHlink"/>
+  <p:sldLayoutIdLst>
+    <p:sldLayoutId r:id="rId1"/>
+    <p:sldLayoutId r:id="rId2"/>
+    <p:sldLayoutId r:id="rId3"/>
+    <p:sldLayoutId r:id="rId4"/>
+    <p:sldLayoutId r:id="rId5"/>
+    <p:sldLayoutId r:id="rId6"/>
+    <p:sldLayoutId r:id="rId7"/>
+    <p:sldLayoutId r:id="rId8"/>
+    <p:sldLayoutId r:id="rId9"/>
+    <p:sldLayoutId r:id="rId10"/>
+    <p:sldLayoutId r:id="rId11"/>
+  </p:sldLayoutIdLst>
+  <p:txStyles>
+    <p:titleStyle>
+      <a:lvl1pPr algn="ctr" defTabSz="457200" rtl="0" eaLnBrk="1" latinLnBrk="0" hangingPunct="1">
+        <a:spcBef>
+          <a:spcPct val="0"/>
+        </a:spcBef>
+        <a:buNone/>
+        <a:defRPr sz="4400" kern="1200">
+          <a:solidFill>
+            <a:schemeClr val="tx1"/>
+          </a:solidFill>
+          <a:latin typeface="+mj-lt"/>
+          <a:ea typeface="+mj-ea"/>
+          <a:cs typeface="+mj-cs"/>
+        </a:defRPr>
+      </a:lvl1pPr>
+    </p:titleStyle>
+    <p:bodyStyle>
+      <a:lvl1pPr marL="342900" indent="-342900" algn="l" defTabSz="457200" rtl="0" eaLnBrk="1" latinLnBrk="0" hangingPunct="1">
+        <a:spcBef>
+          <a:spcPct val="20000"/>
+        </a:spcBef>
+        <a:buFont typeface="Arial"/>
+        <a:buChar char="•"/>
+        <a:defRPr sz="3200" kern="1200">
+          <a:solidFill>
+            <a:schemeClr val="tx1"/>
+          </a:solidFill>
+          <a:latin typeface="+mn-lt"/>
+          <a:ea typeface="+mn-ea"/>
+          <a:cs typeface="+mn-cs"/>
+        </a:defRPr>
+      </a:lvl1pPr>
+      <a:lvl2pPr marL="742950" indent="-285750" algn="l" defTabSz="457200" rtl="0" eaLnBrk="1" latinLnBrk="0" hangingPunct="1">
+        <a:spcBef>
+          <a:spcPct val="20000"/>
+        </a:spcBef>
+        <a:buFont typeface="Arial"/>
+        <a:buChar char="–"/>
+        <a:defRPr sz="2800" kern="1200">
+          <a:solidFill>
+            <a:schemeClr val="tx1"/>
+          </a:solidFill>
+          <a:latin typeface="+mn-lt"/>
+          <a:ea typeface="+mn-ea"/>
+          <a:cs typeface="+mn-cs"/>
+        </a:defRPr>
+      </a:lvl2pPr>
+      <a:lvl3pPr marL="1143000" indent="-228600" algn="l" defTabSz="457200" rtl="0" eaLnBrk="1" latinLnBrk="0" hangingPunct="1">
+        <a:spcBef>
+          <a:spcPct val="20000"/>
+        </a:spcBef>
+        <a:buFont typeface="Arial"/>
+        <a:buChar char="•"/>
+        <a:defRPr sz="2400" kern="1200">
+          <a:solidFill>
+            <a:schemeClr val="tx1"/>
+          </a:solidFill>
+          <a:latin typeface="+mn-lt"/>
+          <a:ea typeface="+mn-ea"/>
+          <a:cs typeface="+mn-cs"/>
+        </a:defRPr>
+      </a:lvl3pPr>
+      <a:lvl4pPr marL="1600200" indent="-228600" algn="l" defTabSz="457200" rtl="0" eaLnBrk="1" latinLnBrk="0" hangingPunct="1">
+        <a:spcBef>
+          <a:spcPct val="20000"/>
+        </a:spcBef>
+        <a:buFont typeface="Arial"/>
+        <a:buChar char="–"/>
+        <a:defRPr sz="2000" kern="1200">
+          <a:solidFill>
+            <a:schemeClr val="tx1"/>
+          </a:solidFill>
+          <a:latin typeface="+mn-lt"/>
+          <a:ea typeface="+mn-ea"/>
+          <a:cs typeface="+mn-cs"/>
+        </a:defRPr>
+      </a:lvl4pPr>
+      <a:lvl5pPr marL="2057400" indent="-228600" algn="l" defTabSz="457200" rtl="0" eaLnBrk="1" latinLnBrk="0" hangingPunct="1">
+        <a:spcBef>
+          <a:spcPct val="20000"/>
+        </a:spcBef>
+        <a:buFont typeface="Arial"/>
+        <a:buChar char="»"/>
+        <a:defRPr sz="2000" kern="1200">
+          <a:solidFill>
+            <a:schemeClr val="tx1"/>
+          </a:solidFill>
+          <a:latin typeface="+mn-lt"/>
+          <a:ea typeface="+mn-ea"/>
+          <a:cs typeface="+mn-cs"/>
+        </a:defRPr>
+      </a:lvl5pPr>
+      <a:lvl6pPr marL="2514600" indent="-228600" algn="l" defTabSz="457200" rtl="0" eaLnBrk="1" latinLnBrk="0" hangingPunct="1">
+        <a:spcBef>
+          <a:spcPct val="20000"/>
+        </a:spcBef>
+        <a:buFont typeface="Arial"/>
+        <a:buChar char="•"/>
+        <a:defRPr sz="2000" kern="1200">
+          <a:solidFill>
+            <a:schemeClr val="tx1"/>
+          </a:solidFill>
+          <a:latin typeface="+mn-lt"/>
+          <a:ea typeface="+mn-ea"/>
+          <a:cs typeface="+mn-cs"/>
+        </a:defRPr>
+      </a:lvl6pPr>
+      <a:lvl7pPr marL="2971800" indent="-228600" algn="l" defTabSz="457200" rtl="0" eaLnBrk="1" latinLnBrk="0" hangingPunct="1">
+        <a:spcBef>
+          <a:spcPct val="20000"/>
+        </a:spcBef>
+        <a:buFont typeface="Arial"/>
+        <a:buChar char="•"/>
+        <a:defRPr sz="2000" kern="1200">
+          <a:solidFill>
+            <a:schemeClr val="tx1"/>
+          </a:solidFill>
+          <a:latin typeface="+mn-lt"/>
+          <a:ea typeface="+mn-ea"/>
+          <a:cs typeface="+mn-cs"/>
+        </a:defRPr>
+      </a:lvl7pPr>
+      <a:lvl8pPr marL="3429000" indent="-228600" algn="l" defTabSz="457200" rtl="0" eaLnBrk="1" latinLnBrk="0" hangingPunct="1">
+        <a:spcBef>
+          <a:spcPct val="20000"/>
+        </a:spcBef>
+        <a:buFont typeface="Arial"/>
+        <a:buChar char="•"/>
+        <a:defRPr sz="2000" kern="1200">
+          <a:solidFill>
+            <a:schemeClr val="tx1"/>
+          </a:solidFill>
+          <a:latin typeface="+mn-lt"/>
+          <a:ea typeface="+mn-ea"/>
+          <a:cs typeface="+mn-cs"/>
+        </a:defRPr>
+      </a:lvl8pPr>
+      <a:lvl9pPr marL="3886200" indent="-228600" algn="l" defTabSz="457200" rtl="0" eaLnBrk="1" latinLnBrk="0" hangingPunct="1">
+        <a:spcBef>
+          <a:spcPct val="20000"/>
+        </a:spcBef>
+        <a:buFont typeface="Arial"/>
+        <a:buChar char="•"/>
+        <a:defRPr sz="2000" kern="1200">
+          <a:solidFill>
+            <a:schemeClr val="tx1"/>
+          </a:solidFill>
+          <a:latin typeface="+mn-lt"/>
+          <a:ea typeface="+mn-ea"/>
+          <a:cs typeface="+mn-cs"/>
+        </a:defRPr>
+      </a:lvl9pPr>
+    </p:bodyStyle>
+    <p:otherStyle>
+      <a:defPPr>
+        <a:defRPr lang="en-US"/>
+      </a:defPPr>
+      <a:lvl1pPr marL="0" algn="l" defTabSz="457200" rtl="0" eaLnBrk="1" latinLnBrk="0" hangingPunct="1">
+        <a:defRPr sz="1800" kern="1200">
+          <a:solidFill>
+            <a:schemeClr val="tx1"/>
+          </a:solidFill>
+          <a:latin typeface="+mn-lt"/>
+          <a:ea typeface="+mn-ea"/>
+          <a:cs typeface="+mn-cs"/>
+        </a:defRPr>
+      </a:lvl1pPr>
+      <a:lvl2pPr marL="457200" algn="l" defTabSz="457200" rtl="0" eaLnBrk="1" latinLnBrk="0" hangingPunct="1">
+        <a:defRPr sz="1800" kern="1200">
+          <a:solidFill>
+            <a:schemeClr val="tx1"/>
+          </a:solidFill>
+          <a:latin typeface="+mn-lt"/>
+          <a:ea typeface="+mn-ea"/>
+          <a:cs typeface="+mn-cs"/>
+        </a:defRPr>
+      </a:lvl2pPr>
+      <a:lvl3pPr marL="914400" algn="l" defTabSz="457200" rtl="0" eaLnBrk="1" latinLnBrk="0" hangingPunct="1">
+        <a:defRPr sz="1800" kern="1200">
+          <a:solidFill>
+            <a:schemeClr val="tx1"/>
+          </a:solidFill>
+          <a:latin typeface="+mn-lt"/>
+          <a:ea typeface="+mn-ea"/>
+          <a:cs typeface="+mn-cs"/>
+        </a:defRPr>
+      </a:lvl3pPr>
+      <a:lvl4pPr marL="1371600" algn="l" defTabSz="457200" rtl="0" eaLnBrk="1" latinLnBrk="0" hangingPunct="1">
+        <a:defRPr sz="1800" kern="1200">
+          <a:solidFill>
+            <a:schemeClr val="tx1"/>
+          </a:solidFill>
+          <a:latin typeface="+mn-lt"/>
+          <a:ea typeface="+mn-ea"/>
+          <a:cs typeface="+mn-cs"/>
+        </a:defRPr>
+      </a:lvl4pPr>
+      <a:lvl5pPr marL="1828800" algn="l" defTabSz="457200" rtl="0" eaLnBrk="1" latinLnBrk="0" hangingPunct="1">
+        <a:defRPr sz="1800" kern="1200">
+          <a:solidFill>
+            <a:schemeClr val="tx1"/>
+          </a:solidFill>
+          <a:latin typeface="+mn-lt"/>
+          <a:ea typeface="+mn-ea"/>
+          <a:cs typeface="+mn-cs"/>
+        </a:defRPr>
+      </a:lvl5pPr>
+      <a:lvl6pPr marL="2286000" algn="l" defTabSz="457200" rtl="0" eaLnBrk="1" latinLnBrk="0" hangingPunct="1">
+        <a:defRPr sz="1800" kern="1200">
+          <a:solidFill>
+            <a:schemeClr val="tx1"/>
+          </a:solidFill>
+          <a:latin typeface="+mn-lt"/>
+          <a:ea typeface="+mn-ea"/>
+          <a:cs typeface="+mn-cs"/>
+        </a:defRPr>
+      </a:lvl6pPr>
+      <a:lvl7pPr marL="2743200" algn="l" defTabSz="457200" rtl="0" eaLnBrk="1" latinLnBrk="0" hangingPunct="1">
+        <a:defRPr sz="1800" kern="1200">
+          <a:solidFill>
+            <a:schemeClr val="tx1"/>
+          </a:solidFill>
+          <a:latin typeface="+mn-lt"/>
+          <a:ea typeface="+mn-ea"/>
+          <a:cs typeface="+mn-cs"/>
+        </a:defRPr>
+      </a:lvl7pPr>
+      <a:lvl8pPr marL="3200400" algn="l" defTabSz="457200" rtl="0" eaLnBrk="1" latinLnBrk="0" hangingPunct="1">
+        <a:defRPr sz="1800" kern="1200">
+          <a:solidFill>
+            <a:schemeClr val="tx1"/>
+          </a:solidFill>
+          <a:latin typeface="+mn-lt"/>
+          <a:ea typeface="+mn-ea"/>
+          <a:cs typeface="+mn-cs"/>
+        </a:defRPr>
+      </a:lvl8pPr>
+      <a:lvl9pPr marL="3657600" algn="l" defTabSz="457200" rtl="0" eaLnBrk="1" latinLnBrk="0" hangingPunct="1">
+        <a:defRPr sz="1800" kern="1200">
+          <a:solidFill>
+            <a:schemeClr val="tx1"/>
+          </a:solidFill>
+          <a:latin typeface="+mn-lt"/>
+          <a:ea typeface="+mn-ea"/>
+          <a:cs typeface="+mn-cs"/>
+        </a:defRPr>
+      </a:lvl9pPr>
+    </p:otherStyle>
+  </p:txStyles>
+</p:sldMaster>
+</file>
+
+<file path=ppt/slides/slide1.xml><?xml version="1.0" encoding="utf-8"?>
+<p:sld xmlns:a="http://schemas.openxmlformats.org/drawingml/2006/main" xmlns:r="http://schemas.openxmlformats.org/officeDocument/2006/relationships" xmlns:mc="http://schemas.openxmlformats.org/markup-compatibility/2006" xmlns:mv="urn:schemas-microsoft-com:mac:vml" xmlns:p="http://schemas.openxmlformats.org/presentationml/2006/main" mc:Ignorable="mv" mc:PreserveAttributes="mv:*">
+  <p:cSld>
+    <p:spTree>
+      <p:nvGrpSpPr>
+        <p:cNvPr id="1" name=""/>
+        <p:cNvGrpSpPr/>
+        <p:nvPr/>
+      </p:nvGrpSpPr>
+      <p:grpSpPr>
+        <a:xfrm>
+          <a:off x="0" y="0"/>
+          <a:ext cx="0" cy="0"/>
+          <a:chOff x="0" y="0"/>
+          <a:chExt cx="0" cy="0"/>
+        </a:xfrm>
+      </p:grpSpPr>
+      <p:cxnSp>
+        <p:nvCxnSpPr>
+          <p:cNvPr id="48" name="Straight Connector 47"/>
+          <p:cNvCxnSpPr/>
+          <p:nvPr/>
+        </p:nvCxnSpPr>
+        <p:spPr>
+          <a:xfrm rot="5400000">
+            <a:off x="7048747" y="3162053"/>
+            <a:ext cx="228600" cy="494"/>
+          </a:xfrm>
+          <a:prstGeom prst="line">
+            <a:avLst/>
+          </a:prstGeom>
+        </p:spPr>
+        <p:style>
+          <a:lnRef idx="2">
+            <a:schemeClr val="accent1"/>
+          </a:lnRef>
+          <a:fillRef idx="0">
+            <a:schemeClr val="accent1"/>
+          </a:fillRef>
+          <a:effectRef idx="1">
+            <a:schemeClr val="accent1"/>
+          </a:effectRef>
+          <a:fontRef idx="minor">
+            <a:schemeClr val="tx1"/>
+          </a:fontRef>
+        </p:style>
+      </p:cxnSp>
+      <p:cxnSp>
+        <p:nvCxnSpPr>
+          <p:cNvPr id="36" name="Straight Connector 35"/>
+          <p:cNvCxnSpPr/>
+          <p:nvPr/>
+        </p:nvCxnSpPr>
+        <p:spPr>
+          <a:xfrm rot="5400000">
+            <a:off x="4039520" y="4076575"/>
+            <a:ext cx="228600" cy="1840"/>
+          </a:xfrm>
+          <a:prstGeom prst="line">
+            <a:avLst/>
+          </a:prstGeom>
+        </p:spPr>
+        <p:style>
+          <a:lnRef idx="2">
+            <a:schemeClr val="accent1"/>
+          </a:lnRef>
+          <a:fillRef idx="0">
+            <a:schemeClr val="accent1"/>
+          </a:fillRef>
+          <a:effectRef idx="1">
+            <a:schemeClr val="accent1"/>
+          </a:effectRef>
+          <a:fontRef idx="minor">
+            <a:schemeClr val="tx1"/>
+          </a:fontRef>
+        </p:style>
+      </p:cxnSp>
+      <p:cxnSp>
+        <p:nvCxnSpPr>
+          <p:cNvPr id="16" name="Straight Connector 15"/>
+          <p:cNvCxnSpPr>
+            <a:stCxn id="8" idx="2"/>
+          </p:cNvCxnSpPr>
+          <p:nvPr/>
+        </p:nvCxnSpPr>
+        <p:spPr>
+          <a:xfrm rot="5400000">
+            <a:off x="2972497" y="3162698"/>
+            <a:ext cx="230188" cy="794"/>
+          </a:xfrm>
+          <a:prstGeom prst="line">
+            <a:avLst/>
+          </a:prstGeom>
+        </p:spPr>
+        <p:style>
+          <a:lnRef idx="2">
+            <a:schemeClr val="accent1"/>
+          </a:lnRef>
+          <a:fillRef idx="0">
+            <a:schemeClr val="accent1"/>
+          </a:fillRef>
+          <a:effectRef idx="1">
+            <a:schemeClr val="accent1"/>
+          </a:effectRef>
+          <a:fontRef idx="minor">
+            <a:schemeClr val="tx1"/>
+          </a:fontRef>
+        </p:style>
+      </p:cxnSp>
+      <p:cxnSp>
+        <p:nvCxnSpPr>
+          <p:cNvPr id="20" name="Straight Connector 19"/>
+          <p:cNvCxnSpPr>
+            <a:stCxn id="9" idx="2"/>
+          </p:cNvCxnSpPr>
+          <p:nvPr/>
+        </p:nvCxnSpPr>
+        <p:spPr>
+          <a:xfrm rot="5400000">
+            <a:off x="4343099" y="3162302"/>
+            <a:ext cx="228602" cy="1588"/>
+          </a:xfrm>
+          <a:prstGeom prst="line">
+            <a:avLst/>
+          </a:prstGeom>
+        </p:spPr>
+        <p:style>
+          <a:lnRef idx="2">
+            <a:schemeClr val="accent1"/>
+          </a:lnRef>
+          <a:fillRef idx="0">
+            <a:schemeClr val="accent1"/>
+          </a:fillRef>
+          <a:effectRef idx="1">
+            <a:schemeClr val="accent1"/>
+          </a:effectRef>
+          <a:fontRef idx="minor">
+            <a:schemeClr val="tx1"/>
+          </a:fontRef>
+        </p:style>
+      </p:cxnSp>
+      <p:cxnSp>
+        <p:nvCxnSpPr>
+          <p:cNvPr id="22" name="Straight Connector 21"/>
+          <p:cNvCxnSpPr>
+            <a:stCxn id="10" idx="2"/>
+          </p:cNvCxnSpPr>
+          <p:nvPr/>
+        </p:nvCxnSpPr>
+        <p:spPr>
+          <a:xfrm rot="5400000">
+            <a:off x="5714947" y="3162054"/>
+            <a:ext cx="228600" cy="494"/>
+          </a:xfrm>
+          <a:prstGeom prst="line">
+            <a:avLst/>
+          </a:prstGeom>
+        </p:spPr>
+        <p:style>
+          <a:lnRef idx="2">
+            <a:schemeClr val="accent1"/>
+          </a:lnRef>
+          <a:fillRef idx="0">
+            <a:schemeClr val="accent1"/>
+          </a:fillRef>
+          <a:effectRef idx="1">
+            <a:schemeClr val="accent1"/>
+          </a:effectRef>
+          <a:fontRef idx="minor">
+            <a:schemeClr val="tx1"/>
+          </a:fontRef>
+        </p:style>
+      </p:cxnSp>
+      <p:sp>
+        <p:nvSpPr>
+          <p:cNvPr id="5" name="Rectangle 4"/>
+          <p:cNvSpPr/>
+          <p:nvPr/>
+        </p:nvSpPr>
+        <p:spPr>
+          <a:xfrm>
+            <a:off x="990600" y="5689600"/>
+            <a:ext cx="6858600" cy="685800"/>
+          </a:xfrm>
+          <a:prstGeom prst="rect">
+            <a:avLst/>
+          </a:prstGeom>
+        </p:spPr>
+        <p:style>
+          <a:lnRef idx="3">
+            <a:schemeClr val="lt1"/>
+          </a:lnRef>
+          <a:fillRef idx="1">
+            <a:schemeClr val="accent4"/>
+          </a:fillRef>
+          <a:effectRef idx="1">
+            <a:schemeClr val="accent4"/>
+          </a:effectRef>
+          <a:fontRef idx="minor">
+            <a:schemeClr val="lt1"/>
+          </a:fontRef>
+        </p:style>
+        <p:txBody>
+          <a:bodyPr rtlCol="0" anchor="ctr"/>
+          <a:lstStyle/>
+          <a:p>
+            <a:pPr algn="ctr"/>
+            <a:r>
+              <a:rPr lang="en-US" dirty="0" smtClean="0"/>
+              <a:t>Bluetooth Single/Dual Mode Chipset</a:t>
+            </a:r>
+            <a:endParaRPr lang="en-US" dirty="0"/>
+          </a:p>
+        </p:txBody>
+      </p:sp>
+      <p:sp>
+        <p:nvSpPr>
+          <p:cNvPr id="6" name="Rectangle 5"/>
+          <p:cNvSpPr/>
+          <p:nvPr/>
+        </p:nvSpPr>
+        <p:spPr>
+          <a:xfrm>
+            <a:off x="990600" y="4191001"/>
+            <a:ext cx="6858600" cy="609600"/>
+          </a:xfrm>
+          <a:prstGeom prst="rect">
+            <a:avLst/>
+          </a:prstGeom>
+        </p:spPr>
+        <p:style>
+          <a:lnRef idx="3">
+            <a:schemeClr val="lt1"/>
+          </a:lnRef>
+          <a:fillRef idx="1">
+            <a:schemeClr val="accent1"/>
+          </a:fillRef>
+          <a:effectRef idx="1">
+            <a:schemeClr val="accent1"/>
+          </a:effectRef>
+          <a:fontRef idx="minor">
+            <a:schemeClr val="lt1"/>
+          </a:fontRef>
+        </p:style>
+        <p:txBody>
+          <a:bodyPr rtlCol="0" anchor="ctr"/>
+          <a:lstStyle/>
+          <a:p>
+            <a:pPr algn="ctr"/>
+            <a:r>
+              <a:rPr lang="en-US" dirty="0" smtClean="0"/>
+              <a:t>HCI</a:t>
+            </a:r>
+            <a:endParaRPr lang="en-US" dirty="0"/>
+          </a:p>
+        </p:txBody>
+      </p:sp>
+      <p:sp>
+        <p:nvSpPr>
+          <p:cNvPr id="7" name="Rectangle 6"/>
+          <p:cNvSpPr/>
+          <p:nvPr/>
+        </p:nvSpPr>
+        <p:spPr>
+          <a:xfrm>
+            <a:off x="990601" y="3276601"/>
+            <a:ext cx="4190400" cy="685800"/>
+          </a:xfrm>
+          <a:prstGeom prst="rect">
+            <a:avLst/>
+          </a:prstGeom>
+        </p:spPr>
+        <p:style>
+          <a:lnRef idx="3">
+            <a:schemeClr val="lt1"/>
+          </a:lnRef>
+          <a:fillRef idx="1">
+            <a:schemeClr val="accent1"/>
+          </a:fillRef>
+          <a:effectRef idx="1">
+            <a:schemeClr val="accent1"/>
+          </a:effectRef>
+          <a:fontRef idx="minor">
+            <a:schemeClr val="lt1"/>
+          </a:fontRef>
+        </p:style>
+        <p:txBody>
+          <a:bodyPr rtlCol="0" anchor="ctr"/>
+          <a:lstStyle/>
+          <a:p>
+            <a:pPr algn="ctr"/>
+            <a:r>
+              <a:rPr lang="en-US" dirty="0" smtClean="0"/>
+              <a:t>L2CAP</a:t>
+            </a:r>
+            <a:endParaRPr lang="en-US" dirty="0"/>
+          </a:p>
+        </p:txBody>
+      </p:sp>
+      <p:sp>
+        <p:nvSpPr>
+          <p:cNvPr id="8" name="Rectangle 7"/>
+          <p:cNvSpPr/>
+          <p:nvPr/>
+        </p:nvSpPr>
+        <p:spPr>
+          <a:xfrm>
+            <a:off x="2439988" y="2438401"/>
+            <a:ext cx="1296000" cy="609600"/>
+          </a:xfrm>
+          <a:prstGeom prst="rect">
+            <a:avLst/>
+          </a:prstGeom>
+        </p:spPr>
+        <p:style>
+          <a:lnRef idx="3">
+            <a:schemeClr val="lt1"/>
+          </a:lnRef>
+          <a:fillRef idx="1">
+            <a:schemeClr val="accent1"/>
+          </a:fillRef>
+          <a:effectRef idx="1">
+            <a:schemeClr val="accent1"/>
+          </a:effectRef>
+          <a:fontRef idx="minor">
+            <a:schemeClr val="lt1"/>
+          </a:fontRef>
+        </p:style>
+        <p:txBody>
+          <a:bodyPr rtlCol="0" anchor="ctr"/>
+          <a:lstStyle/>
+          <a:p>
+            <a:pPr algn="ctr"/>
+            <a:r>
+              <a:rPr lang="en-US" dirty="0" smtClean="0"/>
+              <a:t>SDP</a:t>
+            </a:r>
+            <a:endParaRPr lang="en-US" dirty="0"/>
+          </a:p>
+        </p:txBody>
+      </p:sp>
+      <p:sp>
+        <p:nvSpPr>
+          <p:cNvPr id="9" name="Rectangle 8"/>
+          <p:cNvSpPr/>
+          <p:nvPr/>
+        </p:nvSpPr>
+        <p:spPr>
+          <a:xfrm>
+            <a:off x="3809400" y="2438401"/>
+            <a:ext cx="1296000" cy="609600"/>
+          </a:xfrm>
+          <a:prstGeom prst="rect">
+            <a:avLst/>
+          </a:prstGeom>
+        </p:spPr>
+        <p:style>
+          <a:lnRef idx="3">
+            <a:schemeClr val="lt1"/>
+          </a:lnRef>
+          <a:fillRef idx="1">
+            <a:schemeClr val="accent1"/>
+          </a:fillRef>
+          <a:effectRef idx="1">
+            <a:schemeClr val="accent1"/>
+          </a:effectRef>
+          <a:fontRef idx="minor">
+            <a:schemeClr val="lt1"/>
+          </a:fontRef>
+        </p:style>
+        <p:txBody>
+          <a:bodyPr rtlCol="0" anchor="ctr"/>
+          <a:lstStyle/>
+          <a:p>
+            <a:pPr algn="ctr"/>
+            <a:r>
+              <a:rPr lang="en-US" dirty="0" smtClean="0"/>
+              <a:t>RFCOMM</a:t>
+            </a:r>
+            <a:endParaRPr lang="en-US" dirty="0"/>
+          </a:p>
+        </p:txBody>
+      </p:sp>
+      <p:sp>
+        <p:nvSpPr>
+          <p:cNvPr id="10" name="Rectangle 9"/>
+          <p:cNvSpPr/>
+          <p:nvPr/>
+        </p:nvSpPr>
+        <p:spPr>
+          <a:xfrm>
+            <a:off x="5181494" y="2438401"/>
+            <a:ext cx="1296000" cy="609600"/>
+          </a:xfrm>
+          <a:prstGeom prst="rect">
+            <a:avLst/>
+          </a:prstGeom>
+        </p:spPr>
+        <p:style>
+          <a:lnRef idx="3">
+            <a:schemeClr val="lt1"/>
+          </a:lnRef>
+          <a:fillRef idx="1">
+            <a:schemeClr val="accent3"/>
+          </a:fillRef>
+          <a:effectRef idx="1">
+            <a:schemeClr val="accent3"/>
+          </a:effectRef>
+          <a:fontRef idx="minor">
+            <a:schemeClr val="lt1"/>
+          </a:fontRef>
+        </p:style>
+        <p:txBody>
+          <a:bodyPr rtlCol="0" anchor="ctr"/>
+          <a:lstStyle/>
+          <a:p>
+            <a:pPr algn="ctr"/>
+            <a:r>
+              <a:rPr lang="en-US" dirty="0" smtClean="0"/>
+              <a:t>ATT</a:t>
+            </a:r>
+            <a:endParaRPr lang="en-US" dirty="0"/>
+          </a:p>
+        </p:txBody>
+      </p:sp>
+      <p:cxnSp>
+        <p:nvCxnSpPr>
+          <p:cNvPr id="13" name="Straight Connector 12"/>
+          <p:cNvCxnSpPr/>
+          <p:nvPr/>
+        </p:nvCxnSpPr>
+        <p:spPr>
+          <a:xfrm>
+            <a:off x="914400" y="5476320"/>
+            <a:ext cx="6984000" cy="1588"/>
+          </a:xfrm>
+          <a:prstGeom prst="line">
+            <a:avLst/>
+          </a:prstGeom>
+        </p:spPr>
+        <p:style>
+          <a:lnRef idx="2">
+            <a:schemeClr val="accent2"/>
+          </a:lnRef>
+          <a:fillRef idx="0">
+            <a:schemeClr val="accent2"/>
+          </a:fillRef>
+          <a:effectRef idx="1">
+            <a:schemeClr val="accent2"/>
+          </a:effectRef>
+          <a:fontRef idx="minor">
+            <a:schemeClr val="tx1"/>
+          </a:fontRef>
+        </p:style>
+      </p:cxnSp>
+      <p:sp>
+        <p:nvSpPr>
+          <p:cNvPr id="29" name="Rectangle 28"/>
+          <p:cNvSpPr/>
+          <p:nvPr/>
+        </p:nvSpPr>
+        <p:spPr>
+          <a:xfrm>
+            <a:off x="990600" y="4800601"/>
+            <a:ext cx="1324429" cy="457200"/>
+          </a:xfrm>
+          <a:prstGeom prst="rect">
+            <a:avLst/>
+          </a:prstGeom>
+        </p:spPr>
+        <p:style>
+          <a:lnRef idx="3">
+            <a:schemeClr val="lt1"/>
+          </a:lnRef>
+          <a:fillRef idx="1">
+            <a:schemeClr val="accent1"/>
+          </a:fillRef>
+          <a:effectRef idx="1">
+            <a:schemeClr val="accent1"/>
+          </a:effectRef>
+          <a:fontRef idx="minor">
+            <a:schemeClr val="lt1"/>
+          </a:fontRef>
+        </p:style>
+        <p:txBody>
+          <a:bodyPr rtlCol="0" anchor="ctr"/>
+          <a:lstStyle/>
+          <a:p>
+            <a:pPr algn="ctr"/>
+            <a:r>
+              <a:rPr lang="en-US" dirty="0" smtClean="0"/>
+              <a:t>H4 UART</a:t>
+            </a:r>
+            <a:endParaRPr lang="en-US" dirty="0"/>
+          </a:p>
+        </p:txBody>
+      </p:sp>
+      <p:sp>
+        <p:nvSpPr>
+          <p:cNvPr id="30" name="Rectangle 29"/>
+          <p:cNvSpPr/>
+          <p:nvPr/>
+        </p:nvSpPr>
+        <p:spPr>
+          <a:xfrm>
+            <a:off x="2555991" y="4811094"/>
+            <a:ext cx="1863609" cy="446707"/>
+          </a:xfrm>
+          <a:prstGeom prst="rect">
+            <a:avLst/>
+          </a:prstGeom>
+          <a:ln/>
+        </p:spPr>
+        <p:style>
+          <a:lnRef idx="3">
+            <a:schemeClr val="lt1"/>
+          </a:lnRef>
+          <a:fillRef idx="1">
+            <a:schemeClr val="accent1"/>
+          </a:fillRef>
+          <a:effectRef idx="1">
+            <a:schemeClr val="accent1"/>
+          </a:effectRef>
+          <a:fontRef idx="minor">
+            <a:schemeClr val="lt1"/>
+          </a:fontRef>
+        </p:style>
+        <p:txBody>
+          <a:bodyPr/>
+          <a:lstStyle/>
+          <a:p>
+            <a:pPr algn="ctr"/>
+            <a:r>
+              <a:rPr lang="en-US" dirty="0" err="1" smtClean="0"/>
+              <a:t>eHCILL</a:t>
+            </a:r>
+            <a:r>
+              <a:rPr lang="en-US" dirty="0" smtClean="0"/>
+              <a:t> UART </a:t>
+            </a:r>
+            <a:endParaRPr lang="en-US" dirty="0"/>
+          </a:p>
+        </p:txBody>
+      </p:sp>
+      <p:sp>
+        <p:nvSpPr>
+          <p:cNvPr id="32" name="Rectangle 31"/>
+          <p:cNvSpPr/>
+          <p:nvPr/>
+        </p:nvSpPr>
+        <p:spPr>
+          <a:xfrm>
+            <a:off x="6514763" y="4811094"/>
+            <a:ext cx="1333837" cy="446707"/>
+          </a:xfrm>
+          <a:prstGeom prst="rect">
+            <a:avLst/>
+          </a:prstGeom>
+          <a:ln/>
+        </p:spPr>
+        <p:style>
+          <a:lnRef idx="3">
+            <a:schemeClr val="lt1"/>
+          </a:lnRef>
+          <a:fillRef idx="1">
+            <a:schemeClr val="accent1"/>
+          </a:fillRef>
+          <a:effectRef idx="1">
+            <a:schemeClr val="accent1"/>
+          </a:effectRef>
+          <a:fontRef idx="minor">
+            <a:schemeClr val="lt1"/>
+          </a:fontRef>
+        </p:style>
+        <p:txBody>
+          <a:bodyPr/>
+          <a:lstStyle/>
+          <a:p>
+            <a:pPr algn="ctr"/>
+            <a:r>
+              <a:rPr lang="en-US" dirty="0" smtClean="0"/>
+              <a:t>USB</a:t>
+            </a:r>
+            <a:endParaRPr lang="en-US" dirty="0"/>
+          </a:p>
+        </p:txBody>
+      </p:sp>
+      <p:sp>
+        <p:nvSpPr>
+          <p:cNvPr id="33" name="TextBox 32"/>
+          <p:cNvSpPr txBox="1"/>
+          <p:nvPr/>
+        </p:nvSpPr>
+        <p:spPr>
+          <a:xfrm>
+            <a:off x="4871962" y="4888469"/>
+            <a:ext cx="1147838" cy="369332"/>
+          </a:xfrm>
+          <a:prstGeom prst="rect">
+            <a:avLst/>
+          </a:prstGeom>
+          <a:noFill/>
+        </p:spPr>
+        <p:txBody>
+          <a:bodyPr wrap="square" rtlCol="0">
+            <a:spAutoFit/>
+          </a:bodyPr>
+          <a:lstStyle/>
+          <a:p>
+            <a:pPr algn="ctr"/>
+            <a:r>
+              <a:rPr lang="en-US" dirty="0" smtClean="0"/>
+              <a:t>…</a:t>
+            </a:r>
+            <a:endParaRPr lang="en-US" dirty="0"/>
+          </a:p>
+        </p:txBody>
+      </p:sp>
+      <p:cxnSp>
+        <p:nvCxnSpPr>
+          <p:cNvPr id="19" name="Straight Connector 18"/>
+          <p:cNvCxnSpPr/>
+          <p:nvPr/>
+        </p:nvCxnSpPr>
+        <p:spPr>
+          <a:xfrm>
+            <a:off x="914400" y="2209800"/>
+            <a:ext cx="6984000" cy="1588"/>
+          </a:xfrm>
+          <a:prstGeom prst="line">
+            <a:avLst/>
+          </a:prstGeom>
+        </p:spPr>
+        <p:style>
+          <a:lnRef idx="2">
+            <a:schemeClr val="accent2"/>
+          </a:lnRef>
+          <a:fillRef idx="0">
+            <a:schemeClr val="accent2"/>
+          </a:fillRef>
+          <a:effectRef idx="1">
+            <a:schemeClr val="accent2"/>
+          </a:effectRef>
+          <a:fontRef idx="minor">
+            <a:schemeClr val="tx1"/>
+          </a:fontRef>
+        </p:style>
+      </p:cxnSp>
+      <p:sp>
+        <p:nvSpPr>
+          <p:cNvPr id="21" name="Rectangle 20"/>
+          <p:cNvSpPr/>
+          <p:nvPr/>
+        </p:nvSpPr>
+        <p:spPr>
+          <a:xfrm>
+            <a:off x="3809400" y="1371600"/>
+            <a:ext cx="1296000" cy="609600"/>
+          </a:xfrm>
+          <a:prstGeom prst="rect">
+            <a:avLst/>
+          </a:prstGeom>
+          <a:solidFill>
+            <a:schemeClr val="tx1">
+              <a:lumMod val="50000"/>
+              <a:lumOff val="50000"/>
+            </a:schemeClr>
+          </a:solidFill>
+        </p:spPr>
+        <p:style>
+          <a:lnRef idx="3">
+            <a:schemeClr val="lt1"/>
+          </a:lnRef>
+          <a:fillRef idx="1">
+            <a:schemeClr val="accent2"/>
+          </a:fillRef>
+          <a:effectRef idx="1">
+            <a:schemeClr val="accent2"/>
+          </a:effectRef>
+          <a:fontRef idx="minor">
+            <a:schemeClr val="lt1"/>
+          </a:fontRef>
+        </p:style>
+        <p:txBody>
+          <a:bodyPr rtlCol="0" anchor="ctr"/>
+          <a:lstStyle/>
+          <a:p>
+            <a:pPr algn="ctr"/>
+            <a:r>
+              <a:rPr lang="en-US" dirty="0" smtClean="0"/>
+              <a:t>SPP</a:t>
+            </a:r>
+            <a:endParaRPr lang="en-US" dirty="0"/>
+          </a:p>
+        </p:txBody>
+      </p:sp>
+      <p:sp>
+        <p:nvSpPr>
+          <p:cNvPr id="23" name="Rectangle 22"/>
+          <p:cNvSpPr/>
+          <p:nvPr/>
+        </p:nvSpPr>
+        <p:spPr>
+          <a:xfrm>
+            <a:off x="3810000" y="685800"/>
+            <a:ext cx="1295400" cy="609600"/>
+          </a:xfrm>
+          <a:prstGeom prst="rect">
+            <a:avLst/>
+          </a:prstGeom>
+          <a:solidFill>
+            <a:schemeClr val="tx1">
+              <a:lumMod val="50000"/>
+              <a:lumOff val="50000"/>
+            </a:schemeClr>
+          </a:solidFill>
+        </p:spPr>
+        <p:style>
+          <a:lnRef idx="3">
+            <a:schemeClr val="lt1"/>
+          </a:lnRef>
+          <a:fillRef idx="1">
+            <a:schemeClr val="accent2"/>
+          </a:fillRef>
+          <a:effectRef idx="1">
+            <a:schemeClr val="accent2"/>
+          </a:effectRef>
+          <a:fontRef idx="minor">
+            <a:schemeClr val="lt1"/>
+          </a:fontRef>
+        </p:style>
+        <p:txBody>
+          <a:bodyPr rtlCol="0" anchor="ctr"/>
+          <a:lstStyle/>
+          <a:p>
+            <a:pPr algn="ctr"/>
+            <a:r>
+              <a:rPr lang="en-US" dirty="0" smtClean="0"/>
+              <a:t>OBEX</a:t>
+            </a:r>
+            <a:endParaRPr lang="en-US" dirty="0"/>
+          </a:p>
+        </p:txBody>
+      </p:sp>
+      <p:sp>
+        <p:nvSpPr>
+          <p:cNvPr id="37" name="Rectangle 36"/>
+          <p:cNvSpPr/>
+          <p:nvPr/>
+        </p:nvSpPr>
+        <p:spPr>
+          <a:xfrm>
+            <a:off x="5182094" y="1371600"/>
+            <a:ext cx="1295400" cy="609600"/>
+          </a:xfrm>
+          <a:prstGeom prst="rect">
+            <a:avLst/>
+          </a:prstGeom>
+          <a:solidFill>
+            <a:schemeClr val="tx1">
+              <a:lumMod val="50000"/>
+              <a:lumOff val="50000"/>
+            </a:schemeClr>
+          </a:solidFill>
+        </p:spPr>
+        <p:style>
+          <a:lnRef idx="3">
+            <a:schemeClr val="lt1"/>
+          </a:lnRef>
+          <a:fillRef idx="1">
+            <a:schemeClr val="accent2"/>
+          </a:fillRef>
+          <a:effectRef idx="1">
+            <a:schemeClr val="accent2"/>
+          </a:effectRef>
+          <a:fontRef idx="minor">
+            <a:schemeClr val="lt1"/>
+          </a:fontRef>
+        </p:style>
+        <p:txBody>
+          <a:bodyPr rtlCol="0" anchor="ctr"/>
+          <a:lstStyle/>
+          <a:p>
+            <a:pPr algn="ctr"/>
+            <a:r>
+              <a:rPr lang="en-US" dirty="0" smtClean="0"/>
+              <a:t>GATT</a:t>
+            </a:r>
+            <a:endParaRPr lang="en-US" dirty="0"/>
+          </a:p>
+        </p:txBody>
+      </p:sp>
+      <p:sp>
+        <p:nvSpPr>
+          <p:cNvPr id="38" name="Rectangle 37"/>
+          <p:cNvSpPr/>
+          <p:nvPr/>
+        </p:nvSpPr>
+        <p:spPr>
+          <a:xfrm>
+            <a:off x="1066800" y="1371600"/>
+            <a:ext cx="1295400" cy="609600"/>
+          </a:xfrm>
+          <a:prstGeom prst="rect">
+            <a:avLst/>
+          </a:prstGeom>
+          <a:solidFill>
+            <a:schemeClr val="tx1">
+              <a:lumMod val="50000"/>
+              <a:lumOff val="50000"/>
+            </a:schemeClr>
+          </a:solidFill>
+        </p:spPr>
+        <p:style>
+          <a:lnRef idx="3">
+            <a:schemeClr val="lt1"/>
+          </a:lnRef>
+          <a:fillRef idx="1">
+            <a:schemeClr val="accent2"/>
+          </a:fillRef>
+          <a:effectRef idx="1">
+            <a:schemeClr val="accent2"/>
+          </a:effectRef>
+          <a:fontRef idx="minor">
+            <a:schemeClr val="lt1"/>
+          </a:fontRef>
+        </p:style>
+        <p:txBody>
+          <a:bodyPr rtlCol="0" anchor="ctr"/>
+          <a:lstStyle/>
+          <a:p>
+            <a:pPr algn="ctr"/>
+            <a:r>
+              <a:rPr lang="en-US" dirty="0" smtClean="0"/>
+              <a:t>BNEP</a:t>
+            </a:r>
+            <a:endParaRPr lang="en-US" dirty="0"/>
+          </a:p>
+        </p:txBody>
+      </p:sp>
+      <p:sp>
+        <p:nvSpPr>
+          <p:cNvPr id="40" name="Rectangle 39"/>
+          <p:cNvSpPr/>
+          <p:nvPr/>
+        </p:nvSpPr>
+        <p:spPr>
+          <a:xfrm>
+            <a:off x="6553200" y="2438401"/>
+            <a:ext cx="1296000" cy="609600"/>
+          </a:xfrm>
+          <a:prstGeom prst="rect">
+            <a:avLst/>
+          </a:prstGeom>
+        </p:spPr>
+        <p:style>
+          <a:lnRef idx="3">
+            <a:schemeClr val="lt1"/>
+          </a:lnRef>
+          <a:fillRef idx="1">
+            <a:schemeClr val="accent3"/>
+          </a:fillRef>
+          <a:effectRef idx="1">
+            <a:schemeClr val="accent3"/>
+          </a:effectRef>
+          <a:fontRef idx="minor">
+            <a:schemeClr val="lt1"/>
+          </a:fontRef>
+        </p:style>
+        <p:txBody>
+          <a:bodyPr rtlCol="0" anchor="ctr"/>
+          <a:lstStyle/>
+          <a:p>
+            <a:pPr algn="ctr"/>
+            <a:r>
+              <a:rPr lang="en-US" dirty="0" smtClean="0"/>
+              <a:t>SMP</a:t>
+            </a:r>
+            <a:endParaRPr lang="en-US" dirty="0"/>
+          </a:p>
+        </p:txBody>
+      </p:sp>
+      <p:sp>
+        <p:nvSpPr>
+          <p:cNvPr id="41" name="Rectangle 40"/>
+          <p:cNvSpPr/>
+          <p:nvPr/>
+        </p:nvSpPr>
+        <p:spPr>
+          <a:xfrm>
+            <a:off x="2439988" y="1371600"/>
+            <a:ext cx="1296000" cy="609600"/>
+          </a:xfrm>
+          <a:prstGeom prst="rect">
+            <a:avLst/>
+          </a:prstGeom>
+          <a:solidFill>
+            <a:schemeClr val="tx1">
+              <a:lumMod val="50000"/>
+              <a:lumOff val="50000"/>
+            </a:schemeClr>
+          </a:solidFill>
+        </p:spPr>
+        <p:style>
+          <a:lnRef idx="3">
+            <a:schemeClr val="lt1"/>
+          </a:lnRef>
+          <a:fillRef idx="1">
+            <a:schemeClr val="accent2"/>
+          </a:fillRef>
+          <a:effectRef idx="1">
+            <a:schemeClr val="accent2"/>
+          </a:effectRef>
+          <a:fontRef idx="minor">
+            <a:schemeClr val="lt1"/>
+          </a:fontRef>
+        </p:style>
+        <p:txBody>
+          <a:bodyPr rtlCol="0" anchor="ctr"/>
+          <a:lstStyle/>
+          <a:p>
+            <a:pPr algn="ctr"/>
+            <a:r>
+              <a:rPr lang="en-US" dirty="0" smtClean="0"/>
+              <a:t>SDAP</a:t>
+            </a:r>
+            <a:endParaRPr lang="en-US" dirty="0"/>
+          </a:p>
+        </p:txBody>
+      </p:sp>
+      <p:sp>
+        <p:nvSpPr>
+          <p:cNvPr id="44" name="Rectangle 43"/>
+          <p:cNvSpPr/>
+          <p:nvPr/>
+        </p:nvSpPr>
+        <p:spPr>
+          <a:xfrm>
+            <a:off x="5182094" y="3276601"/>
+            <a:ext cx="2667106" cy="685800"/>
+          </a:xfrm>
+          <a:prstGeom prst="rect">
+            <a:avLst/>
+          </a:prstGeom>
+        </p:spPr>
+        <p:style>
+          <a:lnRef idx="3">
+            <a:schemeClr val="lt1"/>
+          </a:lnRef>
+          <a:fillRef idx="1">
+            <a:schemeClr val="accent3"/>
+          </a:fillRef>
+          <a:effectRef idx="1">
+            <a:schemeClr val="accent3"/>
+          </a:effectRef>
+          <a:fontRef idx="minor">
+            <a:schemeClr val="lt1"/>
+          </a:fontRef>
+        </p:style>
+        <p:txBody>
+          <a:bodyPr rtlCol="0" anchor="ctr"/>
+          <a:lstStyle/>
+          <a:p>
+            <a:pPr algn="ctr"/>
+            <a:r>
+              <a:rPr lang="en-US" dirty="0" smtClean="0"/>
+              <a:t>L2CAP LE</a:t>
+            </a:r>
+            <a:endParaRPr lang="en-US" dirty="0"/>
+          </a:p>
+        </p:txBody>
+      </p:sp>
+    </p:spTree>
+  </p:cSld>
+  <p:clrMapOvr>
+    <a:masterClrMapping/>
+  </p:clrMapOvr>
+</p:sld>
+</file>
+
+<file path=ppt/slides/slide2.xml><?xml version="1.0" encoding="utf-8"?>
+<p:sld xmlns:a="http://schemas.openxmlformats.org/drawingml/2006/main" xmlns:r="http://schemas.openxmlformats.org/officeDocument/2006/relationships" xmlns:mc="http://schemas.openxmlformats.org/markup-compatibility/2006" xmlns:mv="urn:schemas-microsoft-com:mac:vml" xmlns:p="http://schemas.openxmlformats.org/presentationml/2006/main" mc:Ignorable="mv" mc:PreserveAttributes="mv:*">
+  <p:cSld>
+    <p:spTree>
+      <p:nvGrpSpPr>
+        <p:cNvPr id="1" name=""/>
+        <p:cNvGrpSpPr/>
+        <p:nvPr/>
+      </p:nvGrpSpPr>
+      <p:grpSpPr>
+        <a:xfrm>
+          <a:off x="0" y="0"/>
+          <a:ext cx="0" cy="0"/>
+          <a:chOff x="0" y="0"/>
+          <a:chExt cx="0" cy="0"/>
+        </a:xfrm>
+      </p:grpSpPr>
+      <p:grpSp>
+        <p:nvGrpSpPr>
+          <p:cNvPr id="67" name="Group 66"/>
+          <p:cNvGrpSpPr/>
+          <p:nvPr/>
+        </p:nvGrpSpPr>
+        <p:grpSpPr>
+          <a:xfrm>
+            <a:off x="914400" y="1371600"/>
+            <a:ext cx="6984000" cy="5003800"/>
+            <a:chOff x="914400" y="1371600"/>
+            <a:chExt cx="6984000" cy="5003800"/>
+          </a:xfrm>
+        </p:grpSpPr>
+        <p:cxnSp>
+          <p:nvCxnSpPr>
+            <p:cNvPr id="41" name="Straight Connector 40"/>
+            <p:cNvCxnSpPr/>
+            <p:nvPr/>
+          </p:nvCxnSpPr>
+          <p:spPr>
+            <a:xfrm rot="5400000">
+              <a:off x="7048747" y="3162053"/>
+              <a:ext cx="228600" cy="494"/>
+            </a:xfrm>
+            <a:prstGeom prst="line">
+              <a:avLst/>
+            </a:prstGeom>
+          </p:spPr>
+          <p:style>
+            <a:lnRef idx="2">
+              <a:schemeClr val="accent1"/>
+            </a:lnRef>
+            <a:fillRef idx="0">
+              <a:schemeClr val="accent1"/>
+            </a:fillRef>
+            <a:effectRef idx="1">
+              <a:schemeClr val="accent1"/>
+            </a:effectRef>
+            <a:fontRef idx="minor">
+              <a:schemeClr val="tx1"/>
+            </a:fontRef>
+          </p:style>
+        </p:cxnSp>
+        <p:cxnSp>
+          <p:nvCxnSpPr>
+            <p:cNvPr id="42" name="Straight Connector 41"/>
+            <p:cNvCxnSpPr/>
+            <p:nvPr/>
+          </p:nvCxnSpPr>
+          <p:spPr>
+            <a:xfrm rot="5400000">
+              <a:off x="4039520" y="4076575"/>
+              <a:ext cx="228600" cy="1840"/>
+            </a:xfrm>
+            <a:prstGeom prst="line">
+              <a:avLst/>
+            </a:prstGeom>
+          </p:spPr>
+          <p:style>
+            <a:lnRef idx="2">
+              <a:schemeClr val="accent1"/>
+            </a:lnRef>
+            <a:fillRef idx="0">
+              <a:schemeClr val="accent1"/>
+            </a:fillRef>
+            <a:effectRef idx="1">
+              <a:schemeClr val="accent1"/>
+            </a:effectRef>
+            <a:fontRef idx="minor">
+              <a:schemeClr val="tx1"/>
+            </a:fontRef>
+          </p:style>
+        </p:cxnSp>
+        <p:cxnSp>
+          <p:nvCxnSpPr>
+            <p:cNvPr id="43" name="Straight Connector 42"/>
+            <p:cNvCxnSpPr>
+              <a:stCxn id="49" idx="2"/>
+            </p:cNvCxnSpPr>
+            <p:nvPr/>
+          </p:nvCxnSpPr>
+          <p:spPr>
+            <a:xfrm rot="5400000">
+              <a:off x="2972497" y="3162698"/>
+              <a:ext cx="230188" cy="794"/>
+            </a:xfrm>
+            <a:prstGeom prst="line">
+              <a:avLst/>
+            </a:prstGeom>
+          </p:spPr>
+          <p:style>
+            <a:lnRef idx="2">
+              <a:schemeClr val="accent1"/>
+            </a:lnRef>
+            <a:fillRef idx="0">
+              <a:schemeClr val="accent1"/>
+            </a:fillRef>
+            <a:effectRef idx="1">
+              <a:schemeClr val="accent1"/>
+            </a:effectRef>
+            <a:fontRef idx="minor">
+              <a:schemeClr val="tx1"/>
+            </a:fontRef>
+          </p:style>
+        </p:cxnSp>
+        <p:cxnSp>
+          <p:nvCxnSpPr>
+            <p:cNvPr id="44" name="Straight Connector 43"/>
+            <p:cNvCxnSpPr>
+              <a:stCxn id="50" idx="2"/>
+            </p:cNvCxnSpPr>
+            <p:nvPr/>
+          </p:nvCxnSpPr>
+          <p:spPr>
+            <a:xfrm rot="5400000">
+              <a:off x="4343099" y="3162302"/>
+              <a:ext cx="228602" cy="1588"/>
+            </a:xfrm>
+            <a:prstGeom prst="line">
+              <a:avLst/>
+            </a:prstGeom>
+          </p:spPr>
+          <p:style>
+            <a:lnRef idx="2">
+              <a:schemeClr val="accent1"/>
+            </a:lnRef>
+            <a:fillRef idx="0">
+              <a:schemeClr val="accent1"/>
+            </a:fillRef>
+            <a:effectRef idx="1">
+              <a:schemeClr val="accent1"/>
+            </a:effectRef>
+            <a:fontRef idx="minor">
+              <a:schemeClr val="tx1"/>
+            </a:fontRef>
+          </p:style>
+        </p:cxnSp>
+        <p:cxnSp>
+          <p:nvCxnSpPr>
+            <p:cNvPr id="45" name="Straight Connector 44"/>
+            <p:cNvCxnSpPr>
+              <a:stCxn id="51" idx="2"/>
+            </p:cNvCxnSpPr>
+            <p:nvPr/>
+          </p:nvCxnSpPr>
+          <p:spPr>
+            <a:xfrm rot="5400000">
+              <a:off x="5714947" y="3162054"/>
+              <a:ext cx="228600" cy="494"/>
+            </a:xfrm>
+            <a:prstGeom prst="line">
+              <a:avLst/>
+            </a:prstGeom>
+          </p:spPr>
+          <p:style>
+            <a:lnRef idx="2">
+              <a:schemeClr val="accent1"/>
+            </a:lnRef>
+            <a:fillRef idx="0">
+              <a:schemeClr val="accent1"/>
+            </a:fillRef>
+            <a:effectRef idx="1">
+              <a:schemeClr val="accent1"/>
+            </a:effectRef>
+            <a:fontRef idx="minor">
+              <a:schemeClr val="tx1"/>
+            </a:fontRef>
+          </p:style>
+        </p:cxnSp>
+        <p:sp>
+          <p:nvSpPr>
+            <p:cNvPr id="46" name="Rectangle 45"/>
+            <p:cNvSpPr/>
+            <p:nvPr/>
+          </p:nvSpPr>
+          <p:spPr>
+            <a:xfrm>
+              <a:off x="990600" y="5689600"/>
+              <a:ext cx="6858600" cy="685800"/>
+            </a:xfrm>
+            <a:prstGeom prst="rect">
+              <a:avLst/>
+            </a:prstGeom>
+            <a:solidFill>
+              <a:schemeClr val="bg1">
+                <a:lumMod val="50000"/>
+              </a:schemeClr>
+            </a:solidFill>
+          </p:spPr>
+          <p:style>
+            <a:lnRef idx="3">
+              <a:schemeClr val="lt1"/>
+            </a:lnRef>
+            <a:fillRef idx="1">
+              <a:schemeClr val="accent4"/>
+            </a:fillRef>
+            <a:effectRef idx="1">
+              <a:schemeClr val="accent4"/>
+            </a:effectRef>
+            <a:fontRef idx="minor">
+              <a:schemeClr val="lt1"/>
+            </a:fontRef>
+          </p:style>
+          <p:txBody>
+            <a:bodyPr rtlCol="0" anchor="ctr"/>
+            <a:lstStyle/>
+            <a:p>
+              <a:pPr algn="ctr"/>
+              <a:r>
+                <a:rPr lang="en-US" dirty="0" smtClean="0"/>
+                <a:t>Bluetooth Single/Dual Mode Chipset</a:t>
+              </a:r>
+              <a:endParaRPr lang="en-US" dirty="0"/>
+            </a:p>
+          </p:txBody>
+        </p:sp>
+        <p:sp>
+          <p:nvSpPr>
+            <p:cNvPr id="47" name="Rectangle 46"/>
+            <p:cNvSpPr/>
+            <p:nvPr/>
+          </p:nvSpPr>
+          <p:spPr>
+            <a:xfrm>
+              <a:off x="990600" y="4191001"/>
+              <a:ext cx="6858600" cy="609600"/>
+            </a:xfrm>
+            <a:prstGeom prst="rect">
+              <a:avLst/>
+            </a:prstGeom>
+          </p:spPr>
+          <p:style>
+            <a:lnRef idx="3">
+              <a:schemeClr val="lt1"/>
+            </a:lnRef>
+            <a:fillRef idx="1">
+              <a:schemeClr val="accent1"/>
+            </a:fillRef>
+            <a:effectRef idx="1">
+              <a:schemeClr val="accent1"/>
+            </a:effectRef>
+            <a:fontRef idx="minor">
+              <a:schemeClr val="lt1"/>
+            </a:fontRef>
+          </p:style>
+          <p:txBody>
+            <a:bodyPr rtlCol="0" anchor="ctr"/>
+            <a:lstStyle/>
+            <a:p>
+              <a:pPr algn="ctr"/>
+              <a:r>
+                <a:rPr lang="en-US" dirty="0" smtClean="0"/>
+                <a:t>HCI</a:t>
+              </a:r>
+              <a:endParaRPr lang="en-US" dirty="0"/>
+            </a:p>
+          </p:txBody>
+        </p:sp>
+        <p:sp>
+          <p:nvSpPr>
+            <p:cNvPr id="48" name="Rectangle 47"/>
+            <p:cNvSpPr/>
+            <p:nvPr/>
+          </p:nvSpPr>
+          <p:spPr>
+            <a:xfrm>
+              <a:off x="991200" y="3276601"/>
+              <a:ext cx="4190400" cy="685800"/>
+            </a:xfrm>
+            <a:prstGeom prst="rect">
+              <a:avLst/>
+            </a:prstGeom>
+          </p:spPr>
+          <p:style>
+            <a:lnRef idx="3">
+              <a:schemeClr val="lt1"/>
+            </a:lnRef>
+            <a:fillRef idx="1">
+              <a:schemeClr val="accent1"/>
+            </a:fillRef>
+            <a:effectRef idx="1">
+              <a:schemeClr val="accent1"/>
+            </a:effectRef>
+            <a:fontRef idx="minor">
+              <a:schemeClr val="lt1"/>
+            </a:fontRef>
+          </p:style>
+          <p:txBody>
+            <a:bodyPr rtlCol="0" anchor="ctr"/>
+            <a:lstStyle/>
+            <a:p>
+              <a:pPr algn="ctr"/>
+              <a:r>
+                <a:rPr lang="en-US" dirty="0" smtClean="0"/>
+                <a:t>L2CAP</a:t>
+              </a:r>
+              <a:endParaRPr lang="en-US" dirty="0"/>
+            </a:p>
+          </p:txBody>
+        </p:sp>
+        <p:sp>
+          <p:nvSpPr>
+            <p:cNvPr id="49" name="Rectangle 48"/>
+            <p:cNvSpPr/>
+            <p:nvPr/>
+          </p:nvSpPr>
+          <p:spPr>
+            <a:xfrm>
+              <a:off x="2439988" y="2438401"/>
+              <a:ext cx="1296000" cy="609600"/>
+            </a:xfrm>
+            <a:prstGeom prst="rect">
+              <a:avLst/>
+            </a:prstGeom>
+          </p:spPr>
+          <p:style>
+            <a:lnRef idx="3">
+              <a:schemeClr val="lt1"/>
+            </a:lnRef>
+            <a:fillRef idx="1">
+              <a:schemeClr val="accent1"/>
+            </a:fillRef>
+            <a:effectRef idx="1">
+              <a:schemeClr val="accent1"/>
+            </a:effectRef>
+            <a:fontRef idx="minor">
+              <a:schemeClr val="lt1"/>
+            </a:fontRef>
+          </p:style>
+          <p:txBody>
+            <a:bodyPr rtlCol="0" anchor="ctr"/>
+            <a:lstStyle/>
+            <a:p>
+              <a:pPr algn="ctr"/>
+              <a:r>
+                <a:rPr lang="en-US" dirty="0" smtClean="0"/>
+                <a:t>SDP</a:t>
+              </a:r>
+              <a:endParaRPr lang="en-US" dirty="0"/>
+            </a:p>
+          </p:txBody>
+        </p:sp>
+        <p:sp>
+          <p:nvSpPr>
+            <p:cNvPr id="50" name="Rectangle 49"/>
+            <p:cNvSpPr/>
+            <p:nvPr/>
+          </p:nvSpPr>
+          <p:spPr>
+            <a:xfrm>
+              <a:off x="3809400" y="2438401"/>
+              <a:ext cx="1296000" cy="609600"/>
+            </a:xfrm>
+            <a:prstGeom prst="rect">
+              <a:avLst/>
+            </a:prstGeom>
+          </p:spPr>
+          <p:style>
+            <a:lnRef idx="3">
+              <a:schemeClr val="lt1"/>
+            </a:lnRef>
+            <a:fillRef idx="1">
+              <a:schemeClr val="accent1"/>
+            </a:fillRef>
+            <a:effectRef idx="1">
+              <a:schemeClr val="accent1"/>
+            </a:effectRef>
+            <a:fontRef idx="minor">
+              <a:schemeClr val="lt1"/>
+            </a:fontRef>
+          </p:style>
+          <p:txBody>
+            <a:bodyPr rtlCol="0" anchor="ctr"/>
+            <a:lstStyle/>
+            <a:p>
+              <a:pPr algn="ctr"/>
+              <a:r>
+                <a:rPr lang="en-US" dirty="0" smtClean="0"/>
+                <a:t>RFCOMM</a:t>
+              </a:r>
+              <a:endParaRPr lang="en-US" dirty="0"/>
+            </a:p>
+          </p:txBody>
+        </p:sp>
+        <p:sp>
+          <p:nvSpPr>
+            <p:cNvPr id="51" name="Rectangle 50"/>
+            <p:cNvSpPr/>
+            <p:nvPr/>
+          </p:nvSpPr>
+          <p:spPr>
+            <a:xfrm>
+              <a:off x="5181494" y="2438401"/>
+              <a:ext cx="1296000" cy="609600"/>
+            </a:xfrm>
+            <a:prstGeom prst="rect">
+              <a:avLst/>
+            </a:prstGeom>
+          </p:spPr>
+          <p:style>
+            <a:lnRef idx="3">
+              <a:schemeClr val="lt1"/>
+            </a:lnRef>
+            <a:fillRef idx="1">
+              <a:schemeClr val="accent3"/>
+            </a:fillRef>
+            <a:effectRef idx="1">
+              <a:schemeClr val="accent3"/>
+            </a:effectRef>
+            <a:fontRef idx="minor">
+              <a:schemeClr val="lt1"/>
+            </a:fontRef>
+          </p:style>
+          <p:txBody>
+            <a:bodyPr rtlCol="0" anchor="ctr"/>
+            <a:lstStyle/>
+            <a:p>
+              <a:pPr algn="ctr"/>
+              <a:r>
+                <a:rPr lang="en-US" dirty="0" smtClean="0"/>
+                <a:t>ATT</a:t>
+              </a:r>
+              <a:endParaRPr lang="en-US" dirty="0"/>
+            </a:p>
+          </p:txBody>
+        </p:sp>
+        <p:cxnSp>
+          <p:nvCxnSpPr>
+            <p:cNvPr id="52" name="Straight Connector 51"/>
+            <p:cNvCxnSpPr/>
+            <p:nvPr/>
+          </p:nvCxnSpPr>
+          <p:spPr>
+            <a:xfrm>
+              <a:off x="914400" y="5476320"/>
+              <a:ext cx="6984000" cy="1588"/>
+            </a:xfrm>
+            <a:prstGeom prst="line">
+              <a:avLst/>
+            </a:prstGeom>
+          </p:spPr>
+          <p:style>
+            <a:lnRef idx="2">
+              <a:schemeClr val="accent2"/>
+            </a:lnRef>
+            <a:fillRef idx="0">
+              <a:schemeClr val="accent2"/>
+            </a:fillRef>
+            <a:effectRef idx="1">
+              <a:schemeClr val="accent2"/>
+            </a:effectRef>
+            <a:fontRef idx="minor">
+              <a:schemeClr val="tx1"/>
+            </a:fontRef>
+          </p:style>
+        </p:cxnSp>
+        <p:sp>
+          <p:nvSpPr>
+            <p:cNvPr id="53" name="Rectangle 52"/>
+            <p:cNvSpPr/>
+            <p:nvPr/>
+          </p:nvSpPr>
+          <p:spPr>
+            <a:xfrm>
+              <a:off x="990600" y="4800601"/>
+              <a:ext cx="1324429" cy="457200"/>
+            </a:xfrm>
+            <a:prstGeom prst="rect">
+              <a:avLst/>
+            </a:prstGeom>
+          </p:spPr>
+          <p:style>
+            <a:lnRef idx="3">
+              <a:schemeClr val="lt1"/>
+            </a:lnRef>
+            <a:fillRef idx="1">
+              <a:schemeClr val="accent1"/>
+            </a:fillRef>
+            <a:effectRef idx="1">
+              <a:schemeClr val="accent1"/>
+            </a:effectRef>
+            <a:fontRef idx="minor">
+              <a:schemeClr val="lt1"/>
+            </a:fontRef>
+          </p:style>
+          <p:txBody>
+            <a:bodyPr rtlCol="0" anchor="ctr"/>
+            <a:lstStyle/>
+            <a:p>
+              <a:pPr algn="ctr"/>
+              <a:r>
+                <a:rPr lang="en-US" dirty="0" smtClean="0"/>
+                <a:t>H4 UART</a:t>
+              </a:r>
+              <a:endParaRPr lang="en-US" dirty="0"/>
+            </a:p>
+          </p:txBody>
+        </p:sp>
+        <p:sp>
+          <p:nvSpPr>
+            <p:cNvPr id="54" name="Rectangle 53"/>
+            <p:cNvSpPr/>
+            <p:nvPr/>
+          </p:nvSpPr>
+          <p:spPr>
+            <a:xfrm>
+              <a:off x="2555991" y="4811094"/>
+              <a:ext cx="1863609" cy="446707"/>
+            </a:xfrm>
+            <a:prstGeom prst="rect">
+              <a:avLst/>
+            </a:prstGeom>
+            <a:ln/>
+          </p:spPr>
+          <p:style>
+            <a:lnRef idx="3">
+              <a:schemeClr val="lt1"/>
+            </a:lnRef>
+            <a:fillRef idx="1">
+              <a:schemeClr val="accent1"/>
+            </a:fillRef>
+            <a:effectRef idx="1">
+              <a:schemeClr val="accent1"/>
+            </a:effectRef>
+            <a:fontRef idx="minor">
+              <a:schemeClr val="lt1"/>
+            </a:fontRef>
+          </p:style>
+          <p:txBody>
+            <a:bodyPr/>
+            <a:lstStyle/>
+            <a:p>
+              <a:pPr algn="ctr"/>
+              <a:r>
+                <a:rPr lang="en-US" dirty="0" err="1" smtClean="0"/>
+                <a:t>eHCILL</a:t>
+              </a:r>
+              <a:r>
+                <a:rPr lang="en-US" dirty="0" smtClean="0"/>
+                <a:t> UART </a:t>
+              </a:r>
+              <a:endParaRPr lang="en-US" dirty="0"/>
+            </a:p>
+          </p:txBody>
+        </p:sp>
+        <p:sp>
+          <p:nvSpPr>
+            <p:cNvPr id="55" name="Rectangle 54"/>
+            <p:cNvSpPr/>
+            <p:nvPr/>
+          </p:nvSpPr>
+          <p:spPr>
+            <a:xfrm>
+              <a:off x="6514763" y="4811094"/>
+              <a:ext cx="1333837" cy="446707"/>
+            </a:xfrm>
+            <a:prstGeom prst="rect">
+              <a:avLst/>
+            </a:prstGeom>
+            <a:ln/>
+          </p:spPr>
+          <p:style>
+            <a:lnRef idx="3">
+              <a:schemeClr val="lt1"/>
+            </a:lnRef>
+            <a:fillRef idx="1">
+              <a:schemeClr val="accent1"/>
+            </a:fillRef>
+            <a:effectRef idx="1">
+              <a:schemeClr val="accent1"/>
+            </a:effectRef>
+            <a:fontRef idx="minor">
+              <a:schemeClr val="lt1"/>
+            </a:fontRef>
+          </p:style>
+          <p:txBody>
+            <a:bodyPr/>
+            <a:lstStyle/>
+            <a:p>
+              <a:pPr algn="ctr"/>
+              <a:r>
+                <a:rPr lang="en-US" dirty="0" smtClean="0"/>
+                <a:t>USB</a:t>
+              </a:r>
+              <a:endParaRPr lang="en-US" dirty="0"/>
+            </a:p>
+          </p:txBody>
+        </p:sp>
+        <p:sp>
+          <p:nvSpPr>
+            <p:cNvPr id="56" name="TextBox 55"/>
+            <p:cNvSpPr txBox="1"/>
+            <p:nvPr/>
+          </p:nvSpPr>
+          <p:spPr>
+            <a:xfrm>
+              <a:off x="4871962" y="4888469"/>
+              <a:ext cx="1147838" cy="369332"/>
+            </a:xfrm>
+            <a:prstGeom prst="rect">
+              <a:avLst/>
+            </a:prstGeom>
+            <a:noFill/>
+          </p:spPr>
+          <p:txBody>
+            <a:bodyPr wrap="square" rtlCol="0">
+              <a:spAutoFit/>
+            </a:bodyPr>
+            <a:lstStyle/>
+            <a:p>
+              <a:pPr algn="ctr"/>
+              <a:r>
+                <a:rPr lang="en-US" dirty="0" smtClean="0"/>
+                <a:t>…</a:t>
+              </a:r>
+              <a:endParaRPr lang="en-US" dirty="0"/>
+            </a:p>
+          </p:txBody>
+        </p:sp>
+        <p:cxnSp>
+          <p:nvCxnSpPr>
+            <p:cNvPr id="57" name="Straight Connector 56"/>
+            <p:cNvCxnSpPr/>
+            <p:nvPr/>
+          </p:nvCxnSpPr>
+          <p:spPr>
+            <a:xfrm>
+              <a:off x="914400" y="2209800"/>
+              <a:ext cx="6984000" cy="1588"/>
+            </a:xfrm>
+            <a:prstGeom prst="line">
+              <a:avLst/>
+            </a:prstGeom>
+          </p:spPr>
+          <p:style>
+            <a:lnRef idx="2">
+              <a:schemeClr val="accent2"/>
+            </a:lnRef>
+            <a:fillRef idx="0">
+              <a:schemeClr val="accent2"/>
+            </a:fillRef>
+            <a:effectRef idx="1">
+              <a:schemeClr val="accent2"/>
+            </a:effectRef>
+            <a:fontRef idx="minor">
+              <a:schemeClr val="tx1"/>
+            </a:fontRef>
+          </p:style>
+        </p:cxnSp>
+        <p:sp>
+          <p:nvSpPr>
+            <p:cNvPr id="58" name="Rectangle 57"/>
+            <p:cNvSpPr/>
+            <p:nvPr/>
+          </p:nvSpPr>
+          <p:spPr>
+            <a:xfrm>
+              <a:off x="3809400" y="1371600"/>
+              <a:ext cx="1296000" cy="609600"/>
+            </a:xfrm>
+            <a:prstGeom prst="rect">
+              <a:avLst/>
+            </a:prstGeom>
+          </p:spPr>
+          <p:style>
+            <a:lnRef idx="3">
+              <a:schemeClr val="lt1"/>
+            </a:lnRef>
+            <a:fillRef idx="1">
+              <a:schemeClr val="accent4"/>
+            </a:fillRef>
+            <a:effectRef idx="1">
+              <a:schemeClr val="accent4"/>
+            </a:effectRef>
+            <a:fontRef idx="minor">
+              <a:schemeClr val="lt1"/>
+            </a:fontRef>
+          </p:style>
+          <p:txBody>
+            <a:bodyPr rtlCol="0" anchor="ctr"/>
+            <a:lstStyle/>
+            <a:p>
+              <a:pPr algn="ctr"/>
+              <a:r>
+                <a:rPr lang="en-US" dirty="0" smtClean="0"/>
+                <a:t>SPP</a:t>
+              </a:r>
+              <a:endParaRPr lang="en-US" dirty="0"/>
+            </a:p>
+          </p:txBody>
+        </p:sp>
+        <p:sp>
+          <p:nvSpPr>
+            <p:cNvPr id="60" name="Rectangle 59"/>
+            <p:cNvSpPr/>
+            <p:nvPr/>
+          </p:nvSpPr>
+          <p:spPr>
+            <a:xfrm>
+              <a:off x="5182094" y="1371600"/>
+              <a:ext cx="1295400" cy="609600"/>
+            </a:xfrm>
+            <a:prstGeom prst="rect">
+              <a:avLst/>
+            </a:prstGeom>
+          </p:spPr>
+          <p:style>
+            <a:lnRef idx="3">
+              <a:schemeClr val="lt1"/>
+            </a:lnRef>
+            <a:fillRef idx="1">
+              <a:schemeClr val="accent4"/>
+            </a:fillRef>
+            <a:effectRef idx="1">
+              <a:schemeClr val="accent4"/>
+            </a:effectRef>
+            <a:fontRef idx="minor">
+              <a:schemeClr val="lt1"/>
+            </a:fontRef>
+          </p:style>
+          <p:txBody>
+            <a:bodyPr rtlCol="0" anchor="ctr"/>
+            <a:lstStyle/>
+            <a:p>
+              <a:pPr algn="ctr"/>
+              <a:r>
+                <a:rPr lang="en-US" dirty="0" smtClean="0"/>
+                <a:t>GATT</a:t>
+              </a:r>
+              <a:endParaRPr lang="en-US" dirty="0"/>
+            </a:p>
+          </p:txBody>
+        </p:sp>
+        <p:sp>
+          <p:nvSpPr>
+            <p:cNvPr id="62" name="Rectangle 61"/>
+            <p:cNvSpPr/>
+            <p:nvPr/>
+          </p:nvSpPr>
+          <p:spPr>
+            <a:xfrm>
+              <a:off x="6553200" y="2438401"/>
+              <a:ext cx="1296000" cy="609600"/>
+            </a:xfrm>
+            <a:prstGeom prst="rect">
+              <a:avLst/>
+            </a:prstGeom>
+          </p:spPr>
+          <p:style>
+            <a:lnRef idx="3">
+              <a:schemeClr val="lt1"/>
+            </a:lnRef>
+            <a:fillRef idx="1">
+              <a:schemeClr val="accent3"/>
+            </a:fillRef>
+            <a:effectRef idx="1">
+              <a:schemeClr val="accent3"/>
+            </a:effectRef>
+            <a:fontRef idx="minor">
+              <a:schemeClr val="lt1"/>
+            </a:fontRef>
+          </p:style>
+          <p:txBody>
+            <a:bodyPr rtlCol="0" anchor="ctr"/>
+            <a:lstStyle/>
+            <a:p>
+              <a:pPr algn="ctr"/>
+              <a:r>
+                <a:rPr lang="en-US" dirty="0" smtClean="0"/>
+                <a:t>SMP</a:t>
+              </a:r>
+              <a:endParaRPr lang="en-US" dirty="0"/>
+            </a:p>
+          </p:txBody>
+        </p:sp>
+        <p:sp>
+          <p:nvSpPr>
+            <p:cNvPr id="64" name="Rectangle 63"/>
+            <p:cNvSpPr/>
+            <p:nvPr/>
+          </p:nvSpPr>
+          <p:spPr>
+            <a:xfrm>
+              <a:off x="5182094" y="3276601"/>
+              <a:ext cx="2667106" cy="685800"/>
+            </a:xfrm>
+            <a:prstGeom prst="rect">
+              <a:avLst/>
+            </a:prstGeom>
+          </p:spPr>
+          <p:style>
+            <a:lnRef idx="3">
+              <a:schemeClr val="lt1"/>
+            </a:lnRef>
+            <a:fillRef idx="1">
+              <a:schemeClr val="accent3"/>
+            </a:fillRef>
+            <a:effectRef idx="1">
+              <a:schemeClr val="accent3"/>
+            </a:effectRef>
+            <a:fontRef idx="minor">
+              <a:schemeClr val="lt1"/>
+            </a:fontRef>
+          </p:style>
+          <p:txBody>
+            <a:bodyPr rtlCol="0" anchor="ctr"/>
+            <a:lstStyle/>
+            <a:p>
+              <a:pPr algn="ctr"/>
+              <a:r>
+                <a:rPr lang="en-US" dirty="0" smtClean="0"/>
+                <a:t>L2CAP LE</a:t>
+              </a:r>
+              <a:endParaRPr lang="en-US" dirty="0"/>
+            </a:p>
+          </p:txBody>
+        </p:sp>
+        <p:sp>
+          <p:nvSpPr>
+            <p:cNvPr id="65" name="Rectangle 64"/>
+            <p:cNvSpPr/>
+            <p:nvPr/>
+          </p:nvSpPr>
+          <p:spPr>
+            <a:xfrm>
+              <a:off x="991200" y="1764268"/>
+              <a:ext cx="882686" cy="369332"/>
+            </a:xfrm>
+            <a:prstGeom prst="rect">
+              <a:avLst/>
+            </a:prstGeom>
+          </p:spPr>
+          <p:txBody>
+            <a:bodyPr wrap="none">
+              <a:spAutoFit/>
+            </a:bodyPr>
+            <a:lstStyle/>
+            <a:p>
+              <a:r>
+                <a:rPr lang="en-US" dirty="0" smtClean="0"/>
+                <a:t>Profiles</a:t>
+              </a:r>
+              <a:endParaRPr lang="en-US" dirty="0"/>
+            </a:p>
+          </p:txBody>
+        </p:sp>
+        <p:sp>
+          <p:nvSpPr>
+            <p:cNvPr id="66" name="Rectangle 65"/>
+            <p:cNvSpPr/>
+            <p:nvPr/>
+          </p:nvSpPr>
+          <p:spPr>
+            <a:xfrm>
+              <a:off x="991200" y="2253735"/>
+              <a:ext cx="1059868" cy="369332"/>
+            </a:xfrm>
+            <a:prstGeom prst="rect">
+              <a:avLst/>
+            </a:prstGeom>
+          </p:spPr>
+          <p:txBody>
+            <a:bodyPr wrap="none">
+              <a:spAutoFit/>
+            </a:bodyPr>
+            <a:lstStyle/>
+            <a:p>
+              <a:r>
+                <a:rPr lang="en-US" dirty="0" smtClean="0"/>
+                <a:t>Protocols</a:t>
+              </a:r>
+              <a:endParaRPr lang="en-US" dirty="0"/>
+            </a:p>
+          </p:txBody>
+        </p:sp>
+      </p:grpSp>
+    </p:spTree>
+  </p:cSld>
+  <p:clrMapOvr>
+    <a:masterClrMapping/>
+  </p:clrMapOvr>
+</p:sld>
 </file>
 
 <file path=ppt/theme/theme1.xml><?xml version="1.0" encoding="utf-8"?>

</xml_diff>